<commit_message>
minor edits to presentation and report. ready for final submission.
</commit_message>
<xml_diff>
--- a/Project2/Reports/Project2_Presentation_summers.pptx
+++ b/Project2/Reports/Project2_Presentation_summers.pptx
@@ -5,7 +5,7 @@
     <p:sldMasterId id="2147483648" r:id="rId1"/>
   </p:sldMasterIdLst>
   <p:notesMasterIdLst>
-    <p:notesMasterId r:id="rId9"/>
+    <p:notesMasterId r:id="rId8"/>
   </p:notesMasterIdLst>
   <p:sldIdLst>
     <p:sldId id="260" r:id="rId2"/>
@@ -14,42 +14,37 @@
     <p:sldId id="264" r:id="rId5"/>
     <p:sldId id="265" r:id="rId6"/>
     <p:sldId id="266" r:id="rId7"/>
-    <p:sldId id="262" r:id="rId8"/>
   </p:sldIdLst>
   <p:sldSz cx="12192000" cy="6858000"/>
   <p:notesSz cx="12192000" cy="6858000"/>
   <p:embeddedFontLst>
     <p:embeddedFont>
       <p:font typeface="GEHAIV+FranklinGothic-Book" panose="02000500000000000000" pitchFamily="2" charset="0"/>
+      <p:regular r:id="rId9"/>
+    </p:embeddedFont>
+    <p:embeddedFont>
+      <p:font typeface="KDMFEK+FranklinGothic-Book" panose="02000500000000000000" pitchFamily="2" charset="0"/>
       <p:regular r:id="rId10"/>
     </p:embeddedFont>
     <p:embeddedFont>
-      <p:font typeface="KDMFEK+FranklinGothic-Book" panose="02000500000000000000" pitchFamily="2" charset="0"/>
+      <p:font typeface="LVLFDH+FranklinGothic-Book" panose="02000500000000000000" pitchFamily="2" charset="0"/>
       <p:regular r:id="rId11"/>
     </p:embeddedFont>
     <p:embeddedFont>
-      <p:font typeface="LVLFDH+FranklinGothic-Book" panose="02000500000000000000" pitchFamily="2" charset="0"/>
+      <p:font typeface="MPIRPG+FranklinGothic-Book" panose="02000500000000000000" pitchFamily="2" charset="0"/>
       <p:regular r:id="rId12"/>
     </p:embeddedFont>
     <p:embeddedFont>
-      <p:font typeface="MPIRPG+FranklinGothic-Book" panose="02000500000000000000" pitchFamily="2" charset="0"/>
+      <p:font typeface="OAGDQN+FranklinGothic-BookItalic" panose="02000500000000000000" pitchFamily="2" charset="0"/>
       <p:regular r:id="rId13"/>
     </p:embeddedFont>
     <p:embeddedFont>
-      <p:font typeface="NOOILK+FranklinGothic-Book" panose="02000500000000000000" pitchFamily="2" charset="0"/>
+      <p:font typeface="VTCKGD+FranklinGothic-Book" panose="02000500000000000000" pitchFamily="2" charset="0"/>
       <p:regular r:id="rId14"/>
     </p:embeddedFont>
     <p:embeddedFont>
-      <p:font typeface="OAGDQN+FranklinGothic-BookItalic" panose="02000500000000000000" pitchFamily="2" charset="0"/>
+      <p:font typeface="WPQCJM+FranklinGothic-Book" panose="02000500000000000000" pitchFamily="2" charset="0"/>
       <p:regular r:id="rId15"/>
-    </p:embeddedFont>
-    <p:embeddedFont>
-      <p:font typeface="VTCKGD+FranklinGothic-Book" panose="02000500000000000000" pitchFamily="2" charset="0"/>
-      <p:regular r:id="rId16"/>
-    </p:embeddedFont>
-    <p:embeddedFont>
-      <p:font typeface="WPQCJM+FranklinGothic-Book" panose="02000500000000000000" pitchFamily="2" charset="0"/>
-      <p:regular r:id="rId17"/>
     </p:embeddedFont>
   </p:embeddedFontLst>
   <p:defaultTextStyle>
@@ -248,7 +243,7 @@
           <a:p>
             <a:fld id="{C8F60B00-F7D7-A048-9DE8-3D2F737BCA40}" type="datetimeFigureOut">
               <a:rPr lang="en-US" smtClean="0"/>
-              <a:t>3/27/26</a:t>
+              <a:t>3/29/26</a:t>
             </a:fld>
             <a:endParaRPr lang="en-US"/>
           </a:p>
@@ -678,17 +673,6 @@
           <a:bodyPr/>
           <a:lstStyle/>
           <a:p>
-            <a:endParaRPr lang="en-US" sz="1200" kern="1200" dirty="0">
-              <a:solidFill>
-                <a:schemeClr val="tx1"/>
-              </a:solidFill>
-              <a:effectLst/>
-              <a:latin typeface="+mn-lt"/>
-              <a:ea typeface="+mn-ea"/>
-              <a:cs typeface="+mn-cs"/>
-            </a:endParaRPr>
-          </a:p>
-          <a:p>
             <a:endParaRPr lang="en-US" dirty="0"/>
           </a:p>
         </p:txBody>
@@ -779,23 +763,6 @@
           <a:bodyPr/>
           <a:lstStyle/>
           <a:p>
-            <a:pPr marL="0" marR="0" lvl="0" indent="0" algn="l" defTabSz="914400" rtl="0" eaLnBrk="1" fontAlgn="auto" latinLnBrk="0" hangingPunct="1">
-              <a:lnSpc>
-                <a:spcPct val="100000"/>
-              </a:lnSpc>
-              <a:spcBef>
-                <a:spcPts val="0"/>
-              </a:spcBef>
-              <a:spcAft>
-                <a:spcPts val="0"/>
-              </a:spcAft>
-              <a:buClrTx/>
-              <a:buSzTx/>
-              <a:buFontTx/>
-              <a:buNone/>
-              <a:tabLst/>
-              <a:defRPr/>
-            </a:pPr>
             <a:r>
               <a:rPr lang="en-US" sz="1200" kern="1200" dirty="0">
                 <a:solidFill>
@@ -806,33 +773,10 @@
                 <a:ea typeface="+mn-ea"/>
                 <a:cs typeface="+mn-cs"/>
               </a:rPr>
-              <a:t>The Outcomes are measured as one-year changes in cognitive ability and mean cortical thickness</a:t>
-            </a:r>
-            <a:r>
-              <a:rPr lang="en-US" dirty="0">
-                <a:effectLst/>
-              </a:rPr>
-              <a:t> (baseline – 1yr)</a:t>
-            </a:r>
-          </a:p>
-          <a:p>
-            <a:pPr marL="0" marR="0" lvl="0" indent="0" algn="l" defTabSz="914400" rtl="0" eaLnBrk="1" fontAlgn="auto" latinLnBrk="0" hangingPunct="1">
-              <a:lnSpc>
-                <a:spcPct val="100000"/>
-              </a:lnSpc>
-              <a:spcBef>
-                <a:spcPts val="0"/>
-              </a:spcBef>
-              <a:spcAft>
-                <a:spcPts val="0"/>
-              </a:spcAft>
-              <a:buClrTx/>
-              <a:buSzTx/>
-              <a:buFontTx/>
-              <a:buNone/>
-              <a:tabLst/>
-              <a:defRPr/>
-            </a:pPr>
+              <a:t>This diagram illustrates the framework used to test our hypotheses.</a:t>
+            </a:r>
+          </a:p>
+          <a:p>
             <a:endParaRPr lang="en-US" sz="1200" kern="1200" dirty="0">
               <a:solidFill>
                 <a:schemeClr val="tx1"/>
@@ -844,23 +788,6 @@
             </a:endParaRPr>
           </a:p>
           <a:p>
-            <a:pPr marL="0" marR="0" lvl="0" indent="0" algn="l" defTabSz="914400" rtl="0" eaLnBrk="1" fontAlgn="auto" latinLnBrk="0" hangingPunct="1">
-              <a:lnSpc>
-                <a:spcPct val="100000"/>
-              </a:lnSpc>
-              <a:spcBef>
-                <a:spcPts val="0"/>
-              </a:spcBef>
-              <a:spcAft>
-                <a:spcPts val="0"/>
-              </a:spcAft>
-              <a:buClrTx/>
-              <a:buSzTx/>
-              <a:buFontTx/>
-              <a:buNone/>
-              <a:tabLst/>
-              <a:defRPr/>
-            </a:pPr>
             <a:r>
               <a:rPr lang="en-US" sz="1200" kern="1200" dirty="0">
                 <a:solidFill>
@@ -871,30 +798,21 @@
                 <a:ea typeface="+mn-ea"/>
                 <a:cs typeface="+mn-cs"/>
               </a:rPr>
-              <a:t>The primary exposures are baseline inflammation for H1a, 1yr change inflammation for H1b, and the interaction of baseline amyloid and inflammation for Aim 2.</a:t>
-            </a:r>
-          </a:p>
-          <a:p>
-            <a:endParaRPr lang="en-US" dirty="0"/>
-          </a:p>
-          <a:p>
-            <a:pPr marL="0" marR="0" lvl="0" indent="0" algn="l" defTabSz="914400" rtl="0" eaLnBrk="1" fontAlgn="auto" latinLnBrk="0" hangingPunct="1">
-              <a:lnSpc>
-                <a:spcPct val="100000"/>
-              </a:lnSpc>
-              <a:spcBef>
-                <a:spcPts val="0"/>
-              </a:spcBef>
-              <a:spcAft>
-                <a:spcPts val="0"/>
-              </a:spcAft>
-              <a:buClrTx/>
-              <a:buSzTx/>
-              <a:buFontTx/>
-              <a:buNone/>
-              <a:tabLst/>
-              <a:defRPr/>
-            </a:pPr>
+              <a:t>To address these aims and hypotheses linear regression models will be fit, which will allow adjustments for covariates and testing of interactions</a:t>
+            </a:r>
+          </a:p>
+          <a:p>
+            <a:endParaRPr lang="en-US" sz="1200" kern="1200" dirty="0">
+              <a:solidFill>
+                <a:schemeClr val="tx1"/>
+              </a:solidFill>
+              <a:effectLst/>
+              <a:latin typeface="+mn-lt"/>
+              <a:ea typeface="+mn-ea"/>
+              <a:cs typeface="+mn-cs"/>
+            </a:endParaRPr>
+          </a:p>
+          <a:p>
             <a:r>
               <a:rPr lang="en-US" sz="1200" kern="1200" dirty="0">
                 <a:solidFill>
@@ -905,27 +823,21 @@
                 <a:ea typeface="+mn-ea"/>
                 <a:cs typeface="+mn-cs"/>
               </a:rPr>
-              <a:t>This diagram summarizes the framework. </a:t>
-            </a:r>
-          </a:p>
-          <a:p>
-            <a:pPr marL="0" marR="0" lvl="0" indent="0" algn="l" defTabSz="914400" rtl="0" eaLnBrk="1" fontAlgn="auto" latinLnBrk="0" hangingPunct="1">
-              <a:lnSpc>
-                <a:spcPct val="100000"/>
-              </a:lnSpc>
-              <a:spcBef>
-                <a:spcPts val="0"/>
-              </a:spcBef>
-              <a:spcAft>
-                <a:spcPts val="0"/>
-              </a:spcAft>
-              <a:buClrTx/>
-              <a:buSzTx/>
-              <a:buFontTx/>
-              <a:buNone/>
-              <a:tabLst/>
-              <a:defRPr/>
-            </a:pPr>
+              <a:t>In the aim 1 models, the two exposures of interest are baseline inflammation and 1yr change in inflammation.</a:t>
+            </a:r>
+          </a:p>
+          <a:p>
+            <a:endParaRPr lang="en-US" sz="1200" kern="1200" dirty="0">
+              <a:solidFill>
+                <a:schemeClr val="tx1"/>
+              </a:solidFill>
+              <a:effectLst/>
+              <a:latin typeface="+mn-lt"/>
+              <a:ea typeface="+mn-ea"/>
+              <a:cs typeface="+mn-cs"/>
+            </a:endParaRPr>
+          </a:p>
+          <a:p>
             <a:r>
               <a:rPr lang="en-US" sz="1200" kern="1200" dirty="0">
                 <a:solidFill>
@@ -936,8 +848,19 @@
                 <a:ea typeface="+mn-ea"/>
                 <a:cs typeface="+mn-cs"/>
               </a:rPr>
-              <a:t>H1a tests whether baseline inflammation predicts change in outcomes, </a:t>
-            </a:r>
+              <a:t>For Aim 2, we will build upon H1a by introducing amyloid status as a binary predictor, to test whether the association between inflammation and outcomes differ by amyloid status</a:t>
+            </a:r>
+          </a:p>
+          <a:p>
+            <a:endParaRPr lang="en-US" sz="1200" kern="1200" dirty="0">
+              <a:solidFill>
+                <a:schemeClr val="tx1"/>
+              </a:solidFill>
+              <a:effectLst/>
+              <a:latin typeface="+mn-lt"/>
+              <a:ea typeface="+mn-ea"/>
+              <a:cs typeface="+mn-cs"/>
+            </a:endParaRPr>
           </a:p>
           <a:p>
             <a:pPr marL="0" marR="0" lvl="0" indent="0" algn="l" defTabSz="914400" rtl="0" eaLnBrk="1" fontAlgn="auto" latinLnBrk="0" hangingPunct="1">
@@ -967,8 +890,36 @@
                 <a:ea typeface="+mn-ea"/>
                 <a:cs typeface="+mn-cs"/>
               </a:rPr>
-              <a:t>H1b tests whether change in inflammation predicts change in outcomes, and </a:t>
-            </a:r>
+              <a:t>Models adjust for baseline covariates, and sensitivity analyses were conducted to assess their role as precision or confounders or mediators</a:t>
+            </a:r>
+          </a:p>
+          <a:p>
+            <a:pPr marL="0" marR="0" lvl="0" indent="0" algn="l" defTabSz="914400" rtl="0" eaLnBrk="1" fontAlgn="auto" latinLnBrk="0" hangingPunct="1">
+              <a:lnSpc>
+                <a:spcPct val="100000"/>
+              </a:lnSpc>
+              <a:spcBef>
+                <a:spcPts val="0"/>
+              </a:spcBef>
+              <a:spcAft>
+                <a:spcPts val="0"/>
+              </a:spcAft>
+              <a:buClrTx/>
+              <a:buSzTx/>
+              <a:buFontTx/>
+              <a:buNone/>
+              <a:tabLst/>
+              <a:defRPr/>
+            </a:pPr>
+            <a:endParaRPr lang="en-US" sz="1200" kern="1200" dirty="0">
+              <a:solidFill>
+                <a:schemeClr val="tx1"/>
+              </a:solidFill>
+              <a:effectLst/>
+              <a:latin typeface="+mn-lt"/>
+              <a:ea typeface="+mn-ea"/>
+              <a:cs typeface="+mn-cs"/>
+            </a:endParaRPr>
           </a:p>
           <a:p>
             <a:pPr marL="0" marR="0" lvl="0" indent="0" algn="l" defTabSz="914400" rtl="0" eaLnBrk="1" fontAlgn="auto" latinLnBrk="0" hangingPunct="1">
@@ -998,8 +949,61 @@
                 <a:ea typeface="+mn-ea"/>
                 <a:cs typeface="+mn-cs"/>
               </a:rPr>
-              <a:t>Aim 2 evaluates whether amyloid deposition modifies the baseline inflammation–outcome relationship.</a:t>
-            </a:r>
+              <a:t>For multiple testing we assumed there's 4 independent tests within each hypothesis</a:t>
+            </a:r>
+          </a:p>
+          <a:p>
+            <a:pPr marL="0" marR="0" lvl="0" indent="0" algn="l" defTabSz="914400" rtl="0" eaLnBrk="1" fontAlgn="auto" latinLnBrk="0" hangingPunct="1">
+              <a:lnSpc>
+                <a:spcPct val="100000"/>
+              </a:lnSpc>
+              <a:spcBef>
+                <a:spcPts val="0"/>
+              </a:spcBef>
+              <a:spcAft>
+                <a:spcPts val="0"/>
+              </a:spcAft>
+              <a:buClrTx/>
+              <a:buSzTx/>
+              <a:buFontTx/>
+              <a:buNone/>
+              <a:tabLst/>
+              <a:defRPr/>
+            </a:pPr>
+            <a:r>
+              <a:rPr lang="en-US" sz="1200" kern="1200" dirty="0">
+                <a:solidFill>
+                  <a:schemeClr val="tx1"/>
+                </a:solidFill>
+                <a:effectLst/>
+                <a:latin typeface="+mn-lt"/>
+                <a:ea typeface="+mn-ea"/>
+                <a:cs typeface="+mn-cs"/>
+              </a:rPr>
+              <a:t>This was based on prelim data that showed strong correlations between predictors and weak correlations between cognitive and cortical outcomes</a:t>
+            </a:r>
+          </a:p>
+          <a:p>
+            <a:endParaRPr lang="en-US" sz="1200" kern="1200" dirty="0">
+              <a:solidFill>
+                <a:schemeClr val="tx1"/>
+              </a:solidFill>
+              <a:effectLst/>
+              <a:latin typeface="+mn-lt"/>
+              <a:ea typeface="+mn-ea"/>
+              <a:cs typeface="+mn-cs"/>
+            </a:endParaRPr>
+          </a:p>
+          <a:p>
+            <a:endParaRPr lang="en-US" sz="1200" kern="1200" dirty="0">
+              <a:solidFill>
+                <a:schemeClr val="tx1"/>
+              </a:solidFill>
+              <a:effectLst/>
+              <a:latin typeface="+mn-lt"/>
+              <a:ea typeface="+mn-ea"/>
+              <a:cs typeface="+mn-cs"/>
+            </a:endParaRPr>
           </a:p>
         </p:txBody>
       </p:sp>
@@ -1110,7 +1114,7 @@
                 <a:ea typeface="+mn-ea"/>
                 <a:cs typeface="+mn-cs"/>
               </a:rPr>
-              <a:t>Across the tested alpha thresholds, we see that moderate correlations—around 0.3 to 0.4—are required to achieve 80% power. </a:t>
+              <a:t>For Aim 1, power was estimated using correlation-based methods across a range of alpha thresholds to account for uncertainty in the number of independent tests</a:t>
             </a:r>
           </a:p>
           <a:p>
@@ -1169,7 +1173,165 @@
                 <a:ea typeface="+mn-ea"/>
                 <a:cs typeface="+mn-cs"/>
               </a:rPr>
-              <a:t>This means we’re well-powered for cortical thickness effects, but the plot shows that we may be underpowered for more modest cognitive associations</a:t>
+              <a:t>The range of alpha was chosen based on prelim data and possibility there could be more independent tests to adjust for</a:t>
+            </a:r>
+          </a:p>
+          <a:p>
+            <a:pPr marL="0" marR="0" lvl="0" indent="0" algn="l" defTabSz="914400" rtl="0" eaLnBrk="1" fontAlgn="auto" latinLnBrk="0" hangingPunct="1">
+              <a:lnSpc>
+                <a:spcPct val="100000"/>
+              </a:lnSpc>
+              <a:spcBef>
+                <a:spcPts val="0"/>
+              </a:spcBef>
+              <a:spcAft>
+                <a:spcPts val="0"/>
+              </a:spcAft>
+              <a:buClrTx/>
+              <a:buSzTx/>
+              <a:buFontTx/>
+              <a:buNone/>
+              <a:tabLst/>
+              <a:defRPr/>
+            </a:pPr>
+            <a:r>
+              <a:rPr lang="en-US" sz="1200" kern="1200" dirty="0">
+                <a:solidFill>
+                  <a:schemeClr val="tx1"/>
+                </a:solidFill>
+                <a:effectLst/>
+                <a:latin typeface="+mn-lt"/>
+                <a:ea typeface="+mn-ea"/>
+                <a:cs typeface="+mn-cs"/>
+              </a:rPr>
+              <a:t>The optimistic alpha assumes there will be 4 independent with the most conservative at 20.</a:t>
+            </a:r>
+            <a:endParaRPr lang="el-GR" sz="1200" kern="1200" dirty="0">
+              <a:solidFill>
+                <a:schemeClr val="tx1"/>
+              </a:solidFill>
+              <a:effectLst/>
+              <a:latin typeface="+mn-lt"/>
+              <a:ea typeface="+mn-ea"/>
+              <a:cs typeface="+mn-cs"/>
+            </a:endParaRPr>
+          </a:p>
+          <a:p>
+            <a:pPr marL="0" marR="0" lvl="0" indent="0" algn="l" defTabSz="914400" rtl="0" eaLnBrk="1" fontAlgn="auto" latinLnBrk="0" hangingPunct="1">
+              <a:lnSpc>
+                <a:spcPct val="100000"/>
+              </a:lnSpc>
+              <a:spcBef>
+                <a:spcPts val="0"/>
+              </a:spcBef>
+              <a:spcAft>
+                <a:spcPts val="0"/>
+              </a:spcAft>
+              <a:buClrTx/>
+              <a:buSzTx/>
+              <a:buFontTx/>
+              <a:buNone/>
+              <a:tabLst/>
+              <a:defRPr/>
+            </a:pPr>
+            <a:endParaRPr lang="en-US" sz="1200" kern="1200" dirty="0">
+              <a:solidFill>
+                <a:schemeClr val="tx1"/>
+              </a:solidFill>
+              <a:effectLst/>
+              <a:latin typeface="+mn-lt"/>
+              <a:ea typeface="+mn-ea"/>
+              <a:cs typeface="+mn-cs"/>
+            </a:endParaRPr>
+          </a:p>
+          <a:p>
+            <a:pPr marL="0" marR="0" lvl="0" indent="0" algn="l" defTabSz="914400" rtl="0" eaLnBrk="1" fontAlgn="auto" latinLnBrk="0" hangingPunct="1">
+              <a:lnSpc>
+                <a:spcPct val="100000"/>
+              </a:lnSpc>
+              <a:spcBef>
+                <a:spcPts val="0"/>
+              </a:spcBef>
+              <a:spcAft>
+                <a:spcPts val="0"/>
+              </a:spcAft>
+              <a:buClrTx/>
+              <a:buSzTx/>
+              <a:buFontTx/>
+              <a:buNone/>
+              <a:tabLst/>
+              <a:defRPr/>
+            </a:pPr>
+            <a:r>
+              <a:rPr lang="en-US" sz="1200" kern="1200" dirty="0">
+                <a:solidFill>
+                  <a:schemeClr val="tx1"/>
+                </a:solidFill>
+                <a:effectLst/>
+                <a:latin typeface="+mn-lt"/>
+                <a:ea typeface="+mn-ea"/>
+                <a:cs typeface="+mn-cs"/>
+              </a:rPr>
+              <a:t>As you see the Choice of alpha didn’t have a huge impact on effect detection to achieve at least 80% power – which was within 4% of each other</a:t>
+            </a:r>
+          </a:p>
+          <a:p>
+            <a:pPr marL="0" marR="0" lvl="0" indent="0" algn="l" defTabSz="914400" rtl="0" eaLnBrk="1" fontAlgn="auto" latinLnBrk="0" hangingPunct="1">
+              <a:lnSpc>
+                <a:spcPct val="100000"/>
+              </a:lnSpc>
+              <a:spcBef>
+                <a:spcPts val="0"/>
+              </a:spcBef>
+              <a:spcAft>
+                <a:spcPts val="0"/>
+              </a:spcAft>
+              <a:buClrTx/>
+              <a:buSzTx/>
+              <a:buFontTx/>
+              <a:buNone/>
+              <a:tabLst/>
+              <a:defRPr/>
+            </a:pPr>
+            <a:endParaRPr lang="en-US" sz="1200" kern="1200" dirty="0">
+              <a:solidFill>
+                <a:schemeClr val="tx1"/>
+              </a:solidFill>
+              <a:effectLst/>
+              <a:latin typeface="+mn-lt"/>
+              <a:ea typeface="+mn-ea"/>
+              <a:cs typeface="+mn-cs"/>
+            </a:endParaRPr>
+          </a:p>
+          <a:p>
+            <a:pPr marL="0" marR="0" lvl="0" indent="0" algn="l" defTabSz="914400" rtl="0" eaLnBrk="1" fontAlgn="auto" latinLnBrk="0" hangingPunct="1">
+              <a:lnSpc>
+                <a:spcPct val="100000"/>
+              </a:lnSpc>
+              <a:spcBef>
+                <a:spcPts val="0"/>
+              </a:spcBef>
+              <a:spcAft>
+                <a:spcPts val="0"/>
+              </a:spcAft>
+              <a:buClrTx/>
+              <a:buSzTx/>
+              <a:buFontTx/>
+              <a:buNone/>
+              <a:tabLst/>
+              <a:defRPr/>
+            </a:pPr>
+            <a:r>
+              <a:rPr lang="en-US" sz="1200" kern="1200" dirty="0">
+                <a:solidFill>
+                  <a:schemeClr val="tx1"/>
+                </a:solidFill>
+                <a:effectLst/>
+                <a:latin typeface="+mn-lt"/>
+                <a:ea typeface="+mn-ea"/>
+                <a:cs typeface="+mn-cs"/>
+              </a:rPr>
+              <a:t>This means that we have enough power to detect moderate associations, but smaller effects may not be detectable</a:t>
             </a:r>
           </a:p>
         </p:txBody>
@@ -1264,10 +1426,19 @@
                 <a:ea typeface="+mn-ea"/>
                 <a:cs typeface="+mn-cs"/>
               </a:rPr>
-              <a:t>To test for mediation, two models were fit – one with and without the binary adherence variable</a:t>
-            </a:r>
-          </a:p>
-          <a:p>
+              <a:t>For Aim 2 and for simplicity, power was evaluated 0.0125, since Aim 1 showed that power wasn’t highly sensitive to alpha.</a:t>
+            </a:r>
+            <a:br>
+              <a:rPr lang="en-US" sz="1200" kern="1200" dirty="0">
+                <a:solidFill>
+                  <a:schemeClr val="tx1"/>
+                </a:solidFill>
+                <a:effectLst/>
+                <a:latin typeface="+mn-lt"/>
+                <a:ea typeface="+mn-ea"/>
+                <a:cs typeface="+mn-cs"/>
+              </a:rPr>
+            </a:br>
             <a:endParaRPr lang="en-US" sz="1200" kern="1200" dirty="0">
               <a:solidFill>
                 <a:schemeClr val="tx1"/>
@@ -1289,7 +1460,7 @@
                 <a:ea typeface="+mn-ea"/>
                 <a:cs typeface="+mn-cs"/>
               </a:rPr>
-              <a:t>When adherence was included in the models, the hard drug coefficients slightly increased in magnitude across all outcomes</a:t>
+              <a:t>Here, we used a two-sample correlation approach to compare associations between amyloid-negative and amyloid-positive groups.</a:t>
             </a:r>
           </a:p>
           <a:p>
@@ -1314,14 +1485,10 @@
                 <a:ea typeface="+mn-ea"/>
                 <a:cs typeface="+mn-cs"/>
               </a:rPr>
-              <a:t>Which resulted in negative proportion mediated estimates and ultimately inconsistent mediation.  This was likely due to sparse data in the adherence category.</a:t>
-            </a:r>
-          </a:p>
-          <a:p>
-            <a:pPr marL="171450" indent="-171450">
-              <a:buFont typeface="Arial" panose="020B0604020202020204" pitchFamily="34" charset="0"/>
-              <a:buChar char="•"/>
-            </a:pPr>
+              <a:t>The results showed that even in our most favorable conditions where we have equal group sizes and larger correlation differences between the groups, we would only have</a:t>
+            </a:r>
+          </a:p>
+          <a:p>
             <a:r>
               <a:rPr lang="en-US" sz="1200" kern="1200" dirty="0">
                 <a:solidFill>
@@ -1332,10 +1499,19 @@
                 <a:ea typeface="+mn-ea"/>
                 <a:cs typeface="+mn-cs"/>
               </a:rPr>
-              <a:t>Which was shown back in the data overview section where only one subject was in the less than 95% grouping</a:t>
-            </a:r>
-          </a:p>
-          <a:p>
+              <a:t>Enough power at 80% to detect a moderately large effect and only gets worse as group sizes start to differ and correlation differences get smaller</a:t>
+            </a:r>
+            <a:br>
+              <a:rPr lang="en-US" sz="1200" kern="1200" dirty="0">
+                <a:solidFill>
+                  <a:schemeClr val="tx1"/>
+                </a:solidFill>
+                <a:effectLst/>
+                <a:latin typeface="+mn-lt"/>
+                <a:ea typeface="+mn-ea"/>
+                <a:cs typeface="+mn-cs"/>
+              </a:rPr>
+            </a:br>
             <a:endParaRPr lang="en-US" sz="1200" kern="1200" dirty="0">
               <a:solidFill>
                 <a:schemeClr val="tx1"/>
@@ -1345,20 +1521,6 @@
               <a:ea typeface="+mn-ea"/>
               <a:cs typeface="+mn-cs"/>
             </a:endParaRPr>
-          </a:p>
-          <a:p>
-            <a:r>
-              <a:rPr lang="en-US" sz="1200" kern="1200" dirty="0">
-                <a:solidFill>
-                  <a:schemeClr val="tx1"/>
-                </a:solidFill>
-                <a:effectLst/>
-                <a:latin typeface="+mn-lt"/>
-                <a:ea typeface="+mn-ea"/>
-                <a:cs typeface="+mn-cs"/>
-              </a:rPr>
-              <a:t>Overall, there was little evidence that adherence explained the association.</a:t>
-            </a:r>
           </a:p>
         </p:txBody>
       </p:sp>
@@ -1442,23 +1604,6 @@
           <a:bodyPr/>
           <a:lstStyle/>
           <a:p>
-            <a:pPr marL="0" marR="0" lvl="0" indent="0" algn="l" defTabSz="914400" rtl="0" eaLnBrk="1" fontAlgn="auto" latinLnBrk="0" hangingPunct="1">
-              <a:lnSpc>
-                <a:spcPct val="100000"/>
-              </a:lnSpc>
-              <a:spcBef>
-                <a:spcPts val="0"/>
-              </a:spcBef>
-              <a:spcAft>
-                <a:spcPts val="0"/>
-              </a:spcAft>
-              <a:buClrTx/>
-              <a:buSzTx/>
-              <a:buFontTx/>
-              <a:buNone/>
-              <a:tabLst/>
-              <a:defRPr/>
-            </a:pPr>
             <a:r>
               <a:rPr lang="en-US" sz="1200" kern="1200" dirty="0">
                 <a:solidFill>
@@ -1469,7 +1614,7 @@
                 <a:ea typeface="+mn-ea"/>
                 <a:cs typeface="+mn-cs"/>
               </a:rPr>
-              <a:t>Overall, these findings suggest that baseline hard drug use is associated with poorer immunologic recovery and lower physical QOL following HAART initiation, but adherence does not appear to meaningfully mediate these associations. Loss to follow-up indicated the age and physical health was associated with dropout</a:t>
+              <a:t>Overall, the proposed sample size of 175 provides adequate power to detect moderate associations in Aim 1.</a:t>
             </a:r>
           </a:p>
           <a:p>
@@ -1485,150 +1630,6 @@
           </a:p>
           <a:p>
             <a:r>
-              <a:rPr lang="en-US" dirty="0"/>
-              <a:t>Limitations:</a:t>
-            </a:r>
-          </a:p>
-          <a:p>
-            <a:pPr marL="171450" indent="-171450">
-              <a:buFont typeface="Arial" panose="020B0604020202020204" pitchFamily="34" charset="0"/>
-              <a:buChar char="•"/>
-            </a:pPr>
-            <a:r>
-              <a:rPr lang="en-US" dirty="0"/>
-              <a:t>Observational studies typically suffer bias from lack of randomization and unmeasured variables</a:t>
-            </a:r>
-          </a:p>
-          <a:p>
-            <a:pPr marL="171450" indent="-171450">
-              <a:buFont typeface="Arial" panose="020B0604020202020204" pitchFamily="34" charset="0"/>
-              <a:buChar char="•"/>
-            </a:pPr>
-            <a:r>
-              <a:rPr lang="en-US" dirty="0"/>
-              <a:t>Adherence was coded as binary and only had one observation for hard drug user with less than 95% this was likely a reason for the negative proportion mediated, so Adherence could not be reliably estimated and should be treated as descriptive </a:t>
-            </a:r>
-          </a:p>
-          <a:p>
-            <a:pPr marL="171450" indent="-171450">
-              <a:buFont typeface="Arial" panose="020B0604020202020204" pitchFamily="34" charset="0"/>
-              <a:buChar char="•"/>
-            </a:pPr>
-            <a:r>
-              <a:rPr lang="en-US" dirty="0"/>
-              <a:t>Further, the Hard drug user group overall was relatively small so we may not have had enough to power to make precise comparisons</a:t>
-            </a:r>
-          </a:p>
-          <a:p>
-            <a:pPr marL="171450" indent="-171450">
-              <a:buFont typeface="Arial" panose="020B0604020202020204" pitchFamily="34" charset="0"/>
-              <a:buChar char="•"/>
-            </a:pPr>
-            <a:r>
-              <a:rPr lang="en-US" dirty="0"/>
-              <a:t>Lastly, while missingness appeared to be associated with age and physical health, which were observed, there may be some dependency on some unmeasured factor that we did not model. So, the missing data mechanism suggests MAR but wasn’t proven</a:t>
-            </a:r>
-          </a:p>
-        </p:txBody>
-      </p:sp>
-      <p:sp>
-        <p:nvSpPr>
-          <p:cNvPr id="4" name="Slide Number Placeholder 3"/>
-          <p:cNvSpPr>
-            <a:spLocks noGrp="1"/>
-          </p:cNvSpPr>
-          <p:nvPr>
-            <p:ph type="sldNum" sz="quarter" idx="5"/>
-          </p:nvPr>
-        </p:nvSpPr>
-        <p:spPr/>
-        <p:txBody>
-          <a:bodyPr/>
-          <a:lstStyle/>
-          <a:p>
-            <a:fld id="{8055A014-AA40-5B4A-A5FD-4F58A1D7AE4A}" type="slidenum">
-              <a:rPr lang="en-US" smtClean="0"/>
-              <a:t>6</a:t>
-            </a:fld>
-            <a:endParaRPr lang="en-US"/>
-          </a:p>
-        </p:txBody>
-      </p:sp>
-    </p:spTree>
-    <p:extLst>
-      <p:ext uri="{BB962C8B-B14F-4D97-AF65-F5344CB8AC3E}">
-        <p14:creationId xmlns:p14="http://schemas.microsoft.com/office/powerpoint/2010/main" val="400297823"/>
-      </p:ext>
-    </p:extLst>
-  </p:cSld>
-  <p:clrMapOvr>
-    <a:masterClrMapping/>
-  </p:clrMapOvr>
-</p:notes>
-</file>
-
-<file path=ppt/notesSlides/notesSlide7.xml><?xml version="1.0" encoding="utf-8"?>
-<p:notes xmlns:a="http://schemas.openxmlformats.org/drawingml/2006/main" xmlns:r="http://schemas.openxmlformats.org/officeDocument/2006/relationships" xmlns:p="http://schemas.openxmlformats.org/presentationml/2006/main">
-  <p:cSld>
-    <p:spTree>
-      <p:nvGrpSpPr>
-        <p:cNvPr id="1" name=""/>
-        <p:cNvGrpSpPr/>
-        <p:nvPr/>
-      </p:nvGrpSpPr>
-      <p:grpSpPr>
-        <a:xfrm>
-          <a:off x="0" y="0"/>
-          <a:ext cx="0" cy="0"/>
-          <a:chOff x="0" y="0"/>
-          <a:chExt cx="0" cy="0"/>
-        </a:xfrm>
-      </p:grpSpPr>
-      <p:sp>
-        <p:nvSpPr>
-          <p:cNvPr id="2" name="Slide Image Placeholder 1"/>
-          <p:cNvSpPr>
-            <a:spLocks noGrp="1" noRot="1" noChangeAspect="1"/>
-          </p:cNvSpPr>
-          <p:nvPr>
-            <p:ph type="sldImg"/>
-          </p:nvPr>
-        </p:nvSpPr>
-        <p:spPr/>
-      </p:sp>
-      <p:sp>
-        <p:nvSpPr>
-          <p:cNvPr id="3" name="Notes Placeholder 2"/>
-          <p:cNvSpPr>
-            <a:spLocks noGrp="1"/>
-          </p:cNvSpPr>
-          <p:nvPr>
-            <p:ph type="body" idx="1"/>
-          </p:nvPr>
-        </p:nvSpPr>
-        <p:spPr/>
-        <p:txBody>
-          <a:bodyPr/>
-          <a:lstStyle/>
-          <a:p>
-            <a:pPr marL="0" marR="0" lvl="0" indent="0" algn="l" defTabSz="914400" rtl="0" eaLnBrk="1" fontAlgn="auto" latinLnBrk="0" hangingPunct="1">
-              <a:lnSpc>
-                <a:spcPct val="100000"/>
-              </a:lnSpc>
-              <a:spcBef>
-                <a:spcPts val="0"/>
-              </a:spcBef>
-              <a:spcAft>
-                <a:spcPts val="0"/>
-              </a:spcAft>
-              <a:buClrTx/>
-              <a:buSzTx/>
-              <a:buFontTx/>
-              <a:buNone/>
-              <a:tabLst/>
-              <a:defRPr/>
-            </a:pPr>
-            <a:r>
               <a:rPr lang="en-US" sz="1200" kern="1200" dirty="0">
                 <a:solidFill>
                   <a:schemeClr val="tx1"/>
@@ -1638,14 +1639,10 @@
                 <a:ea typeface="+mn-ea"/>
                 <a:cs typeface="+mn-cs"/>
               </a:rPr>
-              <a:t>one-year changes in cognitive performance and AD-signature cortical thickness</a:t>
-            </a:r>
-            <a:r>
-              <a:rPr lang="en-US" dirty="0">
-                <a:effectLst/>
-              </a:rPr>
-              <a:t> (baseline – 1yr)</a:t>
-            </a:r>
+              <a:t>For Aim 2, the study is powered to detect moderately large interaction effects, but smaller interaction effects may not be detected.</a:t>
+            </a:r>
+          </a:p>
+          <a:p>
             <a:endParaRPr lang="en-US" sz="1200" kern="1200" dirty="0">
               <a:solidFill>
                 <a:schemeClr val="tx1"/>
@@ -1657,51 +1654,6 @@
             </a:endParaRPr>
           </a:p>
           <a:p>
-            <a:pPr marL="0" marR="0" lvl="0" indent="0" algn="l" defTabSz="914400" rtl="0" eaLnBrk="1" fontAlgn="auto" latinLnBrk="0" hangingPunct="1">
-              <a:lnSpc>
-                <a:spcPct val="100000"/>
-              </a:lnSpc>
-              <a:spcBef>
-                <a:spcPts val="0"/>
-              </a:spcBef>
-              <a:spcAft>
-                <a:spcPts val="0"/>
-              </a:spcAft>
-              <a:buClrTx/>
-              <a:buSzTx/>
-              <a:buFontTx/>
-              <a:buNone/>
-              <a:tabLst/>
-              <a:defRPr/>
-            </a:pPr>
-            <a:endParaRPr lang="en-US" sz="1200" kern="1200" dirty="0">
-              <a:solidFill>
-                <a:schemeClr val="tx1"/>
-              </a:solidFill>
-              <a:effectLst/>
-              <a:latin typeface="+mn-lt"/>
-              <a:ea typeface="+mn-ea"/>
-              <a:cs typeface="+mn-cs"/>
-            </a:endParaRPr>
-          </a:p>
-          <a:p>
-            <a:pPr marL="0" marR="0" lvl="0" indent="0" algn="l" defTabSz="914400" rtl="0" eaLnBrk="1" fontAlgn="auto" latinLnBrk="0" hangingPunct="1">
-              <a:lnSpc>
-                <a:spcPct val="100000"/>
-              </a:lnSpc>
-              <a:spcBef>
-                <a:spcPts val="0"/>
-              </a:spcBef>
-              <a:spcAft>
-                <a:spcPts val="0"/>
-              </a:spcAft>
-              <a:buClrTx/>
-              <a:buSzTx/>
-              <a:buFontTx/>
-              <a:buNone/>
-              <a:tabLst/>
-              <a:defRPr/>
-            </a:pPr>
             <a:r>
               <a:rPr lang="en-US" sz="1200" kern="1200" dirty="0">
                 <a:solidFill>
@@ -1712,7 +1664,7 @@
                 <a:ea typeface="+mn-ea"/>
                 <a:cs typeface="+mn-cs"/>
               </a:rPr>
-              <a:t>Outcomes will be screened for outliers, missingness, and distributional properties using graphical summaries and descriptive statistics, with transformations applied as needed. </a:t>
+              <a:t>Which is important because interaction effects are typically smaller than main effects, which represents a key limitation of the study.</a:t>
             </a:r>
           </a:p>
           <a:p>
@@ -1733,48 +1685,6 @@
               <a:tabLst/>
               <a:defRPr/>
             </a:pPr>
-            <a:endParaRPr lang="en-US" sz="1200" kern="1200" dirty="0">
-              <a:solidFill>
-                <a:schemeClr val="tx1"/>
-              </a:solidFill>
-              <a:effectLst/>
-              <a:latin typeface="+mn-lt"/>
-              <a:ea typeface="+mn-ea"/>
-              <a:cs typeface="+mn-cs"/>
-            </a:endParaRPr>
-          </a:p>
-          <a:p>
-            <a:pPr marL="0" marR="0" lvl="0" indent="0" algn="l" defTabSz="914400" rtl="0" eaLnBrk="1" fontAlgn="auto" latinLnBrk="0" hangingPunct="1">
-              <a:lnSpc>
-                <a:spcPct val="100000"/>
-              </a:lnSpc>
-              <a:spcBef>
-                <a:spcPts val="0"/>
-              </a:spcBef>
-              <a:spcAft>
-                <a:spcPts val="0"/>
-              </a:spcAft>
-              <a:buClrTx/>
-              <a:buSzTx/>
-              <a:buFontTx/>
-              <a:buNone/>
-              <a:tabLst/>
-              <a:defRPr/>
-            </a:pPr>
-            <a:r>
-              <a:rPr lang="en-US" sz="1200" kern="1200" dirty="0">
-                <a:solidFill>
-                  <a:schemeClr val="tx1"/>
-                </a:solidFill>
-                <a:effectLst/>
-                <a:latin typeface="+mn-lt"/>
-                <a:ea typeface="+mn-ea"/>
-                <a:cs typeface="+mn-cs"/>
-              </a:rPr>
-              <a:t>Any participants excluded due to missing data will be compared with the full cohort to evaluate potential bias.</a:t>
-            </a:r>
-          </a:p>
-          <a:p>
             <a:endParaRPr lang="en-US" dirty="0"/>
           </a:p>
         </p:txBody>
@@ -1796,7 +1706,7 @@
           <a:p>
             <a:fld id="{8055A014-AA40-5B4A-A5FD-4F58A1D7AE4A}" type="slidenum">
               <a:rPr lang="en-US" smtClean="0"/>
-              <a:t>7</a:t>
+              <a:t>6</a:t>
             </a:fld>
             <a:endParaRPr lang="en-US"/>
           </a:p>
@@ -1805,7 +1715,7 @@
     </p:spTree>
     <p:extLst>
       <p:ext uri="{BB962C8B-B14F-4D97-AF65-F5344CB8AC3E}">
-        <p14:creationId xmlns:p14="http://schemas.microsoft.com/office/powerpoint/2010/main" val="774045196"/>
+        <p14:creationId xmlns:p14="http://schemas.microsoft.com/office/powerpoint/2010/main" val="400297823"/>
       </p:ext>
     </p:extLst>
   </p:cSld>
@@ -1922,7 +1832,7 @@
           <a:p>
             <a:fld id="{C16525B2-4347-4F72-BAF7-76B19438D329}" type="datetimeFigureOut">
               <a:rPr lang="en-US" smtClean="0"/>
-              <a:t>3/27/26</a:t>
+              <a:t>3/29/26</a:t>
             </a:fld>
             <a:endParaRPr lang="en-US"/>
           </a:p>
@@ -2145,7 +2055,7 @@
           <a:p>
             <a:fld id="{1D8BD707-D9CF-40AE-B4C6-C98DA3205C09}" type="datetimeFigureOut">
               <a:rPr lang="en-US"/>
-              <a:t>3/27/26</a:t>
+              <a:t>3/29/26</a:t>
             </a:fld>
             <a:endParaRPr lang="en-US"/>
           </a:p>
@@ -2399,8 +2309,8 @@
         </p:nvSpPr>
         <p:spPr>
           <a:xfrm>
-            <a:off x="731404" y="2350167"/>
-            <a:ext cx="10729192" cy="1107996"/>
+            <a:off x="731404" y="2636912"/>
+            <a:ext cx="10729192" cy="553998"/>
           </a:xfrm>
           <a:prstGeom prst="rect">
             <a:avLst/>
@@ -2415,7 +2325,7 @@
             <a:pPr algn="ctr"/>
             <a:r>
               <a:rPr lang="en-US" sz="3600" dirty="0"/>
-              <a:t>The Role of Inflammation in Cognitive Decline and Alzheimer’s Disease</a:t>
+              <a:t>The Role of Inflammation in Alzheimer’s Disease</a:t>
             </a:r>
           </a:p>
         </p:txBody>
@@ -2611,25 +2521,7 @@
                 </a:solidFill>
                 <a:cs typeface="KDMFEK+FranklinGothic-Book"/>
               </a:rPr>
-              <a:t>Research</a:t>
-            </a:r>
-            <a:r>
-              <a:rPr lang="en-US" sz="4400" spc="21" dirty="0">
-                <a:solidFill>
-                  <a:srgbClr val="181A0D"/>
-                </a:solidFill>
-                <a:cs typeface="KDMFEK+FranklinGothic-Book"/>
-              </a:rPr>
-              <a:t> </a:t>
-            </a:r>
-            <a:r>
-              <a:rPr lang="en-US" sz="4400" dirty="0">
-                <a:solidFill>
-                  <a:srgbClr val="181A0D"/>
-                </a:solidFill>
-                <a:cs typeface="KDMFEK+FranklinGothic-Book"/>
-              </a:rPr>
-              <a:t>Questions</a:t>
+              <a:t>Study Aims</a:t>
             </a:r>
             <a:endParaRPr sz="4400" dirty="0">
               <a:solidFill>
@@ -2684,7 +2576,7 @@
             </a:r>
             <a:r>
               <a:rPr lang="en-US" sz="2400" dirty="0"/>
-              <a:t>: Higher baseline peripheral inflammatory marker levels will be associated with greater 1-year decline in cognitive outcomes and AD-signature mean cortical thickness </a:t>
+              <a:t>: Higher baseline peripheral inflammatory marker levels will be associated with greater 1-year decline in cognitive measures and AD-signature mean cortical thickness </a:t>
             </a:r>
           </a:p>
           <a:p>
@@ -2725,8 +2617,12 @@
               <a:buChar char="q"/>
             </a:pPr>
             <a:r>
+              <a:rPr lang="en-US" sz="2400" b="1" i="1" dirty="0"/>
+              <a:t>H2</a:t>
+            </a:r>
+            <a:r>
               <a:rPr lang="en-US" sz="2400" dirty="0"/>
-              <a:t>Amyloid deposition will modify the association between inflammation markers and 1-year decline in memory and AD-signature cortical thickness. </a:t>
+              <a:t>: Amyloid deposition will modify the association between inflammation markers and 1-year decline in cognitive and AD-signature cortical thickness. </a:t>
             </a:r>
             <a:endParaRPr lang="en-US" sz="2000" dirty="0"/>
           </a:p>
@@ -2770,7 +2666,7 @@
         </p:nvSpPr>
         <p:spPr>
           <a:xfrm>
-            <a:off x="0" y="6118"/>
+            <a:off x="0" y="10663"/>
             <a:ext cx="12192000" cy="6858000"/>
           </a:xfrm>
           <a:prstGeom prst="rect">
@@ -2851,8 +2747,8 @@
         </p:nvSpPr>
         <p:spPr>
           <a:xfrm>
-            <a:off x="861876" y="620688"/>
-            <a:ext cx="4665229" cy="7148111"/>
+            <a:off x="852810" y="830278"/>
+            <a:ext cx="3931758" cy="4762842"/>
           </a:xfrm>
           <a:prstGeom prst="rect">
             <a:avLst/>
@@ -2864,12 +2760,137 @@
           </a:bodyPr>
           <a:lstStyle/>
           <a:p>
-            <a:pPr lvl="1">
-              <a:lnSpc>
-                <a:spcPts val="2258"/>
-              </a:lnSpc>
-            </a:pPr>
-            <a:endParaRPr lang="en-US" sz="2400" spc="-25" dirty="0">
+            <a:endParaRPr lang="en-US" sz="2000" b="1" dirty="0"/>
+          </a:p>
+          <a:p>
+            <a:pPr marL="285750" indent="-285750">
+              <a:buFont typeface="Wingdings" pitchFamily="2" charset="2"/>
+              <a:buChar char="q"/>
+            </a:pPr>
+            <a:r>
+              <a:rPr lang="en-US" dirty="0"/>
+              <a:t>Linear regression models </a:t>
+            </a:r>
+          </a:p>
+          <a:p>
+            <a:pPr marL="285750" indent="-285750">
+              <a:buFont typeface="Wingdings" pitchFamily="2" charset="2"/>
+              <a:buChar char="q"/>
+            </a:pPr>
+            <a:endParaRPr lang="en-US" dirty="0"/>
+          </a:p>
+          <a:p>
+            <a:pPr marL="285750" indent="-285750">
+              <a:buFont typeface="Wingdings" pitchFamily="2" charset="2"/>
+              <a:buChar char="q"/>
+            </a:pPr>
+            <a:r>
+              <a:rPr lang="en-US" dirty="0"/>
+              <a:t>Adjust for baseline outcomes + baseline covariates</a:t>
+            </a:r>
+          </a:p>
+          <a:p>
+            <a:pPr marL="742950" lvl="1" indent="-285750">
+              <a:buFont typeface="Wingdings" pitchFamily="2" charset="2"/>
+              <a:buChar char="Ø"/>
+            </a:pPr>
+            <a:r>
+              <a:rPr lang="en-US" dirty="0"/>
+              <a:t>Sensitivity for covariates</a:t>
+            </a:r>
+          </a:p>
+          <a:p>
+            <a:pPr marL="1200150" lvl="2" indent="-285750">
+              <a:buFont typeface="Arial" panose="020B0604020202020204" pitchFamily="34" charset="0"/>
+              <a:buChar char="•"/>
+            </a:pPr>
+            <a:r>
+              <a:rPr lang="en-US" dirty="0"/>
+              <a:t>APOE, CDR, </a:t>
+            </a:r>
+            <a:r>
+              <a:rPr lang="en-US" dirty="0" err="1"/>
+              <a:t>etc</a:t>
+            </a:r>
+            <a:endParaRPr lang="en-US" dirty="0"/>
+          </a:p>
+          <a:p>
+            <a:pPr marL="742950" lvl="1" indent="-285750">
+              <a:buFont typeface="Wingdings" pitchFamily="2" charset="2"/>
+              <a:buChar char="Ø"/>
+            </a:pPr>
+            <a:endParaRPr lang="en-US" dirty="0"/>
+          </a:p>
+          <a:p>
+            <a:pPr marL="285750" indent="-285750">
+              <a:buFont typeface="Wingdings" pitchFamily="2" charset="2"/>
+              <a:buChar char="q"/>
+            </a:pPr>
+            <a:r>
+              <a:rPr lang="en-US" spc="-25" dirty="0">
+                <a:solidFill>
+                  <a:srgbClr val="181A0D"/>
+                </a:solidFill>
+              </a:rPr>
+              <a:t>Multiplicity</a:t>
+            </a:r>
+          </a:p>
+          <a:p>
+            <a:pPr marL="742950" lvl="1" indent="-285750">
+              <a:buFont typeface="Wingdings" pitchFamily="2" charset="2"/>
+              <a:buChar char="Ø"/>
+            </a:pPr>
+            <a:r>
+              <a:rPr lang="el-GR" spc="-25" dirty="0">
+                <a:solidFill>
+                  <a:srgbClr val="181A0D"/>
+                </a:solidFill>
+              </a:rPr>
+              <a:t>α=0</a:t>
+            </a:r>
+            <a:r>
+              <a:rPr lang="en-US" spc="-25" dirty="0">
+                <a:solidFill>
+                  <a:srgbClr val="181A0D"/>
+                </a:solidFill>
+              </a:rPr>
+              <a:t>.05/4 independent tests</a:t>
+            </a:r>
+          </a:p>
+          <a:p>
+            <a:pPr marL="742950" lvl="1" indent="-285750">
+              <a:buFont typeface="Wingdings" pitchFamily="2" charset="2"/>
+              <a:buChar char="Ø"/>
+            </a:pPr>
+            <a:r>
+              <a:rPr lang="en-US" spc="-25" dirty="0">
+                <a:solidFill>
+                  <a:srgbClr val="181A0D"/>
+                </a:solidFill>
+              </a:rPr>
+              <a:t>Outcomes (2): Cognitive &amp; Cortical</a:t>
+            </a:r>
+          </a:p>
+          <a:p>
+            <a:pPr marL="742950" lvl="1" indent="-285750">
+              <a:buFont typeface="Wingdings" pitchFamily="2" charset="2"/>
+              <a:buChar char="Ø"/>
+            </a:pPr>
+            <a:r>
+              <a:rPr lang="en-US" spc="-25" dirty="0">
+                <a:solidFill>
+                  <a:srgbClr val="181A0D"/>
+                </a:solidFill>
+              </a:rPr>
+              <a:t>Predictors (2): Cytokines &amp; Chemokines</a:t>
+            </a:r>
+          </a:p>
+          <a:p>
+            <a:pPr marL="285750" indent="-285750">
+              <a:buFont typeface="Wingdings" pitchFamily="2" charset="2"/>
+              <a:buChar char="q"/>
+            </a:pPr>
+            <a:endParaRPr lang="en-US" sz="1600" spc="-25" dirty="0">
               <a:solidFill>
                 <a:srgbClr val="181A0D"/>
               </a:solidFill>
@@ -2877,204 +2898,20 @@
             </a:endParaRPr>
           </a:p>
           <a:p>
-            <a:endParaRPr lang="en-US" sz="2000" dirty="0"/>
-          </a:p>
-          <a:p>
-            <a:pPr>
+            <a:pPr marL="342900" marR="0" indent="-342900">
               <a:lnSpc>
                 <a:spcPts val="2258"/>
               </a:lnSpc>
-            </a:pPr>
-            <a:r>
-              <a:rPr lang="en-US" sz="2000" b="1" dirty="0">
-                <a:solidFill>
-                  <a:srgbClr val="181A0D"/>
-                </a:solidFill>
-              </a:rPr>
-              <a:t>Outcomes (1-yr </a:t>
-            </a:r>
-            <a:r>
-              <a:rPr lang="el-GR" sz="2000" b="1" dirty="0">
-                <a:solidFill>
-                  <a:srgbClr val="181A0D"/>
-                </a:solidFill>
-              </a:rPr>
-              <a:t>Δ</a:t>
-            </a:r>
-            <a:r>
-              <a:rPr lang="en-US" sz="2000" b="1" dirty="0">
-                <a:solidFill>
-                  <a:srgbClr val="181A0D"/>
-                </a:solidFill>
-              </a:rPr>
-              <a:t>; baseline - 1yr</a:t>
-            </a:r>
-            <a:r>
-              <a:rPr lang="el-GR" sz="2000" b="1" dirty="0">
-                <a:solidFill>
-                  <a:srgbClr val="181A0D"/>
-                </a:solidFill>
-              </a:rPr>
-              <a:t>)</a:t>
-            </a:r>
-            <a:r>
-              <a:rPr lang="en-US" sz="2000" b="1" dirty="0">
-                <a:solidFill>
-                  <a:srgbClr val="181A0D"/>
-                </a:solidFill>
-              </a:rPr>
-              <a:t>:</a:t>
-            </a:r>
-          </a:p>
-          <a:p>
-            <a:pPr marL="285750" indent="-285750">
+              <a:spcBef>
+                <a:spcPts val="0"/>
+              </a:spcBef>
+              <a:spcAft>
+                <a:spcPts val="0"/>
+              </a:spcAft>
               <a:buFont typeface="Wingdings" pitchFamily="2" charset="2"/>
               <a:buChar char="q"/>
             </a:pPr>
-            <a:r>
-              <a:rPr lang="en-US" dirty="0"/>
-              <a:t>Cognitive: CVLT, Benson, MST, Store Recall</a:t>
-            </a:r>
-          </a:p>
-          <a:p>
-            <a:pPr marL="285750" indent="-285750">
-              <a:buFont typeface="Wingdings" pitchFamily="2" charset="2"/>
-              <a:buChar char="q"/>
-            </a:pPr>
-            <a:r>
-              <a:rPr lang="en-US" dirty="0"/>
-              <a:t>Brain structure: mean cortical thickness</a:t>
-            </a:r>
-          </a:p>
-          <a:p>
-            <a:pPr lvl="1">
-              <a:lnSpc>
-                <a:spcPts val="2258"/>
-              </a:lnSpc>
-            </a:pPr>
-            <a:endParaRPr lang="en-US" dirty="0">
-              <a:solidFill>
-                <a:srgbClr val="181A0D"/>
-              </a:solidFill>
-            </a:endParaRPr>
-          </a:p>
-          <a:p>
-            <a:r>
-              <a:rPr lang="en-US" sz="2000" b="1" dirty="0"/>
-              <a:t>Exposures:</a:t>
-            </a:r>
-            <a:endParaRPr lang="en-US" sz="2000" dirty="0"/>
-          </a:p>
-          <a:p>
-            <a:pPr marL="285750" indent="-285750">
-              <a:buFont typeface="Wingdings" pitchFamily="2" charset="2"/>
-              <a:buChar char="q"/>
-            </a:pPr>
-            <a:r>
-              <a:rPr lang="en-US" dirty="0"/>
-              <a:t>Baseline inflammation </a:t>
-            </a:r>
-          </a:p>
-          <a:p>
-            <a:pPr marL="742950" lvl="1" indent="-285750">
-              <a:buFont typeface="Wingdings" pitchFamily="2" charset="2"/>
-              <a:buChar char="Ø"/>
-            </a:pPr>
-            <a:r>
-              <a:rPr lang="en-US" dirty="0"/>
-              <a:t>(IL-6, TNF-</a:t>
-            </a:r>
-            <a:r>
-              <a:rPr lang="el-GR" dirty="0"/>
-              <a:t>α, </a:t>
-            </a:r>
-            <a:r>
-              <a:rPr lang="en-US" dirty="0"/>
-              <a:t>MCP-1, Eotaxin-1)</a:t>
-            </a:r>
-          </a:p>
-          <a:p>
-            <a:pPr marL="285750" indent="-285750">
-              <a:buFont typeface="Wingdings" pitchFamily="2" charset="2"/>
-              <a:buChar char="q"/>
-            </a:pPr>
-            <a:r>
-              <a:rPr lang="en-US" dirty="0"/>
-              <a:t>Change in inflammation (baseline → 1 year)</a:t>
-            </a:r>
-          </a:p>
-          <a:p>
-            <a:pPr marL="285750" indent="-285750">
-              <a:buFont typeface="Wingdings" pitchFamily="2" charset="2"/>
-              <a:buChar char="q"/>
-            </a:pPr>
-            <a:r>
-              <a:rPr lang="en-US" dirty="0"/>
-              <a:t>Baseline amyloid (binary) * baseline inflammation (continuous)</a:t>
-            </a:r>
-          </a:p>
-          <a:p>
-            <a:br>
-              <a:rPr lang="en-US" sz="2000" dirty="0"/>
-            </a:br>
-            <a:r>
-              <a:rPr lang="en-US" sz="2000" b="1" dirty="0"/>
-              <a:t>Framework:</a:t>
-            </a:r>
-          </a:p>
-          <a:p>
-            <a:pPr marL="285750" indent="-285750">
-              <a:buFont typeface="Wingdings" pitchFamily="2" charset="2"/>
-              <a:buChar char="q"/>
-            </a:pPr>
-            <a:r>
-              <a:rPr lang="en-US" dirty="0"/>
-              <a:t>Linear regression models</a:t>
-            </a:r>
-          </a:p>
-          <a:p>
-            <a:pPr marL="285750" indent="-285750">
-              <a:buFont typeface="Wingdings" pitchFamily="2" charset="2"/>
-              <a:buChar char="q"/>
-            </a:pPr>
-            <a:r>
-              <a:rPr lang="en-US" dirty="0"/>
-              <a:t>Separate models per outcome</a:t>
-            </a:r>
-          </a:p>
-          <a:p>
-            <a:pPr marL="285750" indent="-285750">
-              <a:buFont typeface="Wingdings" pitchFamily="2" charset="2"/>
-              <a:buChar char="q"/>
-            </a:pPr>
-            <a:r>
-              <a:rPr lang="en-US" dirty="0"/>
-              <a:t>Adjust for baseline covariates + baseline outcome</a:t>
-            </a:r>
-          </a:p>
-          <a:p>
-            <a:pPr marL="285750" indent="-285750">
-              <a:buFont typeface="Wingdings" pitchFamily="2" charset="2"/>
-              <a:buChar char="q"/>
-            </a:pPr>
-            <a:r>
-              <a:rPr lang="en-US" dirty="0"/>
-              <a:t>Holm correction (</a:t>
-            </a:r>
-            <a:r>
-              <a:rPr lang="el-GR" dirty="0"/>
-              <a:t>α = 0.05)</a:t>
-            </a:r>
-          </a:p>
-          <a:p>
-            <a:pPr marL="800100" lvl="1" indent="-342900">
-              <a:lnSpc>
-                <a:spcPts val="2258"/>
-              </a:lnSpc>
-              <a:buFont typeface="Wingdings" pitchFamily="2" charset="2"/>
-              <a:buChar char="q"/>
-            </a:pPr>
-            <a:endParaRPr lang="en-US" sz="2000" spc="-25" dirty="0">
+            <a:endParaRPr lang="en-US" spc="-25" dirty="0">
               <a:solidFill>
                 <a:srgbClr val="181A0D"/>
               </a:solidFill>
@@ -3082,36 +2919,6 @@
             </a:endParaRPr>
           </a:p>
           <a:p>
-            <a:pPr marL="800100" lvl="1" indent="-342900">
-              <a:lnSpc>
-                <a:spcPts val="2258"/>
-              </a:lnSpc>
-              <a:buFont typeface="Wingdings" pitchFamily="2" charset="2"/>
-              <a:buChar char="q"/>
-            </a:pPr>
-            <a:endParaRPr lang="en-US" sz="2000" spc="-25" dirty="0">
-              <a:solidFill>
-                <a:srgbClr val="181A0D"/>
-              </a:solidFill>
-              <a:cs typeface="OAGDQN+FranklinGothic-BookItalic"/>
-            </a:endParaRPr>
-          </a:p>
-          <a:p>
-            <a:pPr marL="800100" lvl="1" indent="-342900">
-              <a:lnSpc>
-                <a:spcPts val="2258"/>
-              </a:lnSpc>
-              <a:buFont typeface="Wingdings" pitchFamily="2" charset="2"/>
-              <a:buChar char="q"/>
-            </a:pPr>
-            <a:endParaRPr lang="en-US" sz="2000" spc="-25" dirty="0">
-              <a:solidFill>
-                <a:srgbClr val="181A0D"/>
-              </a:solidFill>
-              <a:cs typeface="OAGDQN+FranklinGothic-BookItalic"/>
-            </a:endParaRPr>
-          </a:p>
-          <a:p>
             <a:pPr marL="342900" marR="0" indent="-342900">
               <a:lnSpc>
                 <a:spcPts val="2258"/>
@@ -3125,28 +2932,7 @@
               <a:buFont typeface="Wingdings" pitchFamily="2" charset="2"/>
               <a:buChar char="q"/>
             </a:pPr>
-            <a:endParaRPr lang="en-US" sz="2000" spc="-25" dirty="0">
-              <a:solidFill>
-                <a:srgbClr val="181A0D"/>
-              </a:solidFill>
-              <a:cs typeface="OAGDQN+FranklinGothic-BookItalic"/>
-            </a:endParaRPr>
-          </a:p>
-          <a:p>
-            <a:pPr marL="342900" marR="0" indent="-342900">
-              <a:lnSpc>
-                <a:spcPts val="2258"/>
-              </a:lnSpc>
-              <a:spcBef>
-                <a:spcPts val="0"/>
-              </a:spcBef>
-              <a:spcAft>
-                <a:spcPts val="0"/>
-              </a:spcAft>
-              <a:buFont typeface="Wingdings" pitchFamily="2" charset="2"/>
-              <a:buChar char="q"/>
-            </a:pPr>
-            <a:endParaRPr lang="en-US" sz="2000" spc="-25" dirty="0">
+            <a:endParaRPr lang="en-US" spc="-25" dirty="0">
               <a:solidFill>
                 <a:srgbClr val="181A0D"/>
               </a:solidFill>
@@ -3190,8 +2976,8 @@
         </p:nvSpPr>
         <p:spPr>
           <a:xfrm>
-            <a:off x="5830710" y="2842895"/>
-            <a:ext cx="1765004" cy="761563"/>
+            <a:off x="4970380" y="3575226"/>
+            <a:ext cx="2300631" cy="1175289"/>
           </a:xfrm>
           <a:prstGeom prst="roundRect">
             <a:avLst/>
@@ -3217,12 +3003,27 @@
           <a:p>
             <a:pPr algn="ctr"/>
             <a:r>
-              <a:rPr lang="en-US" sz="1600" dirty="0">
+              <a:rPr lang="en-US" sz="1600" b="1" dirty="0">
                 <a:solidFill>
                   <a:schemeClr val="tx1"/>
                 </a:solidFill>
               </a:rPr>
               <a:t>Baseline Inflammation</a:t>
+            </a:r>
+          </a:p>
+          <a:p>
+            <a:pPr algn="ctr"/>
+            <a:r>
+              <a:rPr lang="en-US" sz="1600" dirty="0"/>
+              <a:t>(IL-6, TNF-</a:t>
+            </a:r>
+            <a:r>
+              <a:rPr lang="el-GR" sz="1600" dirty="0"/>
+              <a:t>α, </a:t>
+            </a:r>
+            <a:r>
+              <a:rPr lang="en-US" sz="1600" dirty="0"/>
+              <a:t>MCP-1, Eotaxin-1)</a:t>
             </a:r>
           </a:p>
         </p:txBody>
@@ -3241,8 +3042,8 @@
         </p:nvSpPr>
         <p:spPr>
           <a:xfrm>
-            <a:off x="9793506" y="3399591"/>
-            <a:ext cx="2127642" cy="1477171"/>
+            <a:off x="9641478" y="3523210"/>
+            <a:ext cx="2271889" cy="1680564"/>
           </a:xfrm>
           <a:prstGeom prst="roundRect">
             <a:avLst/>
@@ -3266,9 +3067,18 @@
           <a:bodyPr rtlCol="0" anchor="ctr"/>
           <a:lstStyle/>
           <a:p>
+            <a:pPr algn="ctr"/>
+            <a:r>
+              <a:rPr lang="en-US" sz="1600" b="1" dirty="0"/>
+              <a:t>1-year Change (baseline </a:t>
+            </a:r>
             <a:r>
               <a:rPr lang="en-US" sz="1600" dirty="0"/>
-              <a:t>1-year Change in:</a:t>
+              <a:t>→</a:t>
+            </a:r>
+            <a:r>
+              <a:rPr lang="en-US" sz="1600" b="1" dirty="0"/>
+              <a:t> 1yr):</a:t>
             </a:r>
           </a:p>
           <a:p>
@@ -3299,8 +3109,8 @@
         </p:nvSpPr>
         <p:spPr>
           <a:xfrm>
-            <a:off x="5824758" y="4526453"/>
-            <a:ext cx="1765004" cy="761563"/>
+            <a:off x="4948802" y="5300067"/>
+            <a:ext cx="2358305" cy="1175289"/>
           </a:xfrm>
           <a:prstGeom prst="roundRect">
             <a:avLst/>
@@ -3326,12 +3136,19 @@
           <a:p>
             <a:pPr algn="ctr"/>
             <a:r>
-              <a:rPr lang="el-GR" sz="1600" dirty="0"/>
+              <a:rPr lang="el-GR" sz="1600" b="1" dirty="0"/>
               <a:t>Δ </a:t>
             </a:r>
             <a:r>
+              <a:rPr lang="en-US" sz="1600" b="1" dirty="0"/>
+              <a:t>Inflammation</a:t>
+            </a:r>
+          </a:p>
+          <a:p>
+            <a:pPr algn="ctr"/>
+            <a:r>
               <a:rPr lang="en-US" sz="1600" dirty="0"/>
-              <a:t>Inflammation</a:t>
+              <a:t>(baseline → 1yr)</a:t>
             </a:r>
           </a:p>
         </p:txBody>
@@ -3350,8 +3167,8 @@
         </p:nvSpPr>
         <p:spPr>
           <a:xfrm>
-            <a:off x="7589762" y="1188693"/>
-            <a:ext cx="1765004" cy="835805"/>
+            <a:off x="6153862" y="1509069"/>
+            <a:ext cx="2271890" cy="1175289"/>
           </a:xfrm>
           <a:prstGeom prst="roundRect">
             <a:avLst/>
@@ -3377,7 +3194,7 @@
           <a:p>
             <a:pPr algn="ctr"/>
             <a:r>
-              <a:rPr lang="en-US" sz="1600" dirty="0"/>
+              <a:rPr lang="en-US" sz="1600" b="1" dirty="0"/>
               <a:t>Baseline Amyloid</a:t>
             </a:r>
             <a:br>
@@ -3385,7 +3202,7 @@
             </a:br>
             <a:r>
               <a:rPr lang="en-US" sz="1600" dirty="0"/>
-              <a:t>(high vs low)</a:t>
+              <a:t>(Binary: Pos vs Neg)</a:t>
             </a:r>
           </a:p>
         </p:txBody>
@@ -3405,9 +3222,9 @@
           <p:nvPr/>
         </p:nvCxnSpPr>
         <p:spPr>
-          <a:xfrm>
-            <a:off x="7669304" y="3223677"/>
-            <a:ext cx="1931834" cy="479654"/>
+          <a:xfrm flipV="1">
+            <a:off x="7344584" y="4078680"/>
+            <a:ext cx="2131739" cy="7021"/>
           </a:xfrm>
           <a:prstGeom prst="straightConnector1">
             <a:avLst/>
@@ -3447,13 +3264,19 @@
         </p:nvCxnSpPr>
         <p:spPr>
           <a:xfrm flipV="1">
-            <a:off x="7717389" y="4469623"/>
-            <a:ext cx="1883749" cy="407139"/>
+            <a:off x="7458916" y="5009946"/>
+            <a:ext cx="2017407" cy="877765"/>
           </a:xfrm>
           <a:prstGeom prst="straightConnector1">
             <a:avLst/>
           </a:prstGeom>
           <a:ln>
+            <a:solidFill>
+              <a:schemeClr val="accent2">
+                <a:lumMod val="60000"/>
+                <a:lumOff val="40000"/>
+              </a:schemeClr>
+            </a:solidFill>
             <a:tailEnd type="triangle"/>
           </a:ln>
         </p:spPr>
@@ -3483,20 +3306,21 @@
           </p:cNvPr>
           <p:cNvCxnSpPr>
             <a:cxnSpLocks/>
+            <a:endCxn id="8" idx="2"/>
           </p:cNvCxnSpPr>
           <p:nvPr/>
         </p:nvCxnSpPr>
         <p:spPr>
-          <a:xfrm flipV="1">
-            <a:off x="8472264" y="2098427"/>
-            <a:ext cx="0" cy="1301164"/>
+          <a:xfrm flipH="1" flipV="1">
+            <a:off x="7289807" y="2684358"/>
+            <a:ext cx="1099202" cy="1345023"/>
           </a:xfrm>
           <a:prstGeom prst="straightConnector1">
             <a:avLst/>
           </a:prstGeom>
-          <a:ln w="19050" cap="flat" cmpd="sng" algn="ctr">
+          <a:ln w="25400" cap="flat" cmpd="sng" algn="ctr">
             <a:solidFill>
-              <a:schemeClr val="accent2"/>
+              <a:srgbClr val="92D050"/>
             </a:solidFill>
             <a:prstDash val="dash"/>
             <a:round/>
@@ -3533,8 +3357,8 @@
         </p:nvSpPr>
         <p:spPr>
           <a:xfrm>
-            <a:off x="6388981" y="2486846"/>
-            <a:ext cx="576064" cy="338554"/>
+            <a:off x="5814004" y="3228988"/>
+            <a:ext cx="534647" cy="338554"/>
           </a:xfrm>
           <a:prstGeom prst="rect">
             <a:avLst/>
@@ -3568,8 +3392,8 @@
         </p:nvSpPr>
         <p:spPr>
           <a:xfrm>
-            <a:off x="6340945" y="4194743"/>
-            <a:ext cx="576064" cy="338554"/>
+            <a:off x="5853369" y="4953240"/>
+            <a:ext cx="534652" cy="338554"/>
           </a:xfrm>
           <a:prstGeom prst="rect">
             <a:avLst/>
@@ -3603,8 +3427,8 @@
         </p:nvSpPr>
         <p:spPr>
           <a:xfrm>
-            <a:off x="7506346" y="837878"/>
-            <a:ext cx="1931835" cy="338554"/>
+            <a:off x="6940038" y="1192296"/>
+            <a:ext cx="661945" cy="338554"/>
           </a:xfrm>
           <a:prstGeom prst="rect">
             <a:avLst/>
@@ -3619,8 +3443,252 @@
           <a:p>
             <a:r>
               <a:rPr lang="en-US" sz="1600" dirty="0"/>
-              <a:t>Aim2: Modifies H1a</a:t>
-            </a:r>
+              <a:t>Aim 2</a:t>
+            </a:r>
+          </a:p>
+        </p:txBody>
+      </p:sp>
+      <p:sp>
+        <p:nvSpPr>
+          <p:cNvPr id="13" name="TextBox 12">
+            <a:extLst>
+              <a:ext uri="{FF2B5EF4-FFF2-40B4-BE49-F238E27FC236}">
+                <a16:creationId xmlns:a16="http://schemas.microsoft.com/office/drawing/2014/main" id="{FAF91A9B-A76A-5C73-435B-785DC6BD434C}"/>
+              </a:ext>
+            </a:extLst>
+          </p:cNvPr>
+          <p:cNvSpPr txBox="1"/>
+          <p:nvPr/>
+        </p:nvSpPr>
+        <p:spPr>
+          <a:xfrm>
+            <a:off x="7779501" y="2997073"/>
+            <a:ext cx="1861977" cy="338554"/>
+          </a:xfrm>
+          <a:prstGeom prst="rect">
+            <a:avLst/>
+          </a:prstGeom>
+          <a:noFill/>
+        </p:spPr>
+        <p:txBody>
+          <a:bodyPr wrap="square" rtlCol="0">
+            <a:spAutoFit/>
+          </a:bodyPr>
+          <a:lstStyle/>
+          <a:p>
+            <a:r>
+              <a:rPr lang="en-US" sz="1600" dirty="0"/>
+              <a:t>Modifies H1a</a:t>
+            </a:r>
+          </a:p>
+        </p:txBody>
+      </p:sp>
+      <p:cxnSp>
+        <p:nvCxnSpPr>
+          <p:cNvPr id="34" name="Straight Arrow Connector 33">
+            <a:extLst>
+              <a:ext uri="{FF2B5EF4-FFF2-40B4-BE49-F238E27FC236}">
+                <a16:creationId xmlns:a16="http://schemas.microsoft.com/office/drawing/2014/main" id="{1EEBCFE4-2667-BE03-D22E-78BF3B5D9DD1}"/>
+              </a:ext>
+            </a:extLst>
+          </p:cNvPr>
+          <p:cNvCxnSpPr>
+            <a:cxnSpLocks/>
+          </p:cNvCxnSpPr>
+          <p:nvPr/>
+        </p:nvCxnSpPr>
+        <p:spPr>
+          <a:xfrm>
+            <a:off x="8443423" y="4061967"/>
+            <a:ext cx="919422" cy="23734"/>
+          </a:xfrm>
+          <a:prstGeom prst="straightConnector1">
+            <a:avLst/>
+          </a:prstGeom>
+          <a:ln w="25400" cap="flat" cmpd="sng" algn="ctr">
+            <a:solidFill>
+              <a:srgbClr val="92D050"/>
+            </a:solidFill>
+            <a:prstDash val="dash"/>
+            <a:round/>
+            <a:headEnd type="none" w="med" len="med"/>
+            <a:tailEnd type="none" w="med" len="med"/>
+          </a:ln>
+        </p:spPr>
+        <p:style>
+          <a:lnRef idx="0">
+            <a:scrgbClr r="0" g="0" b="0"/>
+          </a:lnRef>
+          <a:fillRef idx="0">
+            <a:scrgbClr r="0" g="0" b="0"/>
+          </a:fillRef>
+          <a:effectRef idx="0">
+            <a:scrgbClr r="0" g="0" b="0"/>
+          </a:effectRef>
+          <a:fontRef idx="minor">
+            <a:schemeClr val="tx1"/>
+          </a:fontRef>
+        </p:style>
+      </p:cxnSp>
+      <p:sp>
+        <p:nvSpPr>
+          <p:cNvPr id="9" name="Right Brace 8">
+            <a:extLst>
+              <a:ext uri="{FF2B5EF4-FFF2-40B4-BE49-F238E27FC236}">
+                <a16:creationId xmlns:a16="http://schemas.microsoft.com/office/drawing/2014/main" id="{3A9744E8-142B-745C-6803-1C2054EC01AF}"/>
+              </a:ext>
+            </a:extLst>
+          </p:cNvPr>
+          <p:cNvSpPr/>
+          <p:nvPr/>
+        </p:nvSpPr>
+        <p:spPr>
+          <a:xfrm rot="16200000">
+            <a:off x="10554153" y="2354017"/>
+            <a:ext cx="338554" cy="1789212"/>
+          </a:xfrm>
+          <a:prstGeom prst="rightBrace">
+            <a:avLst/>
+          </a:prstGeom>
+        </p:spPr>
+        <p:style>
+          <a:lnRef idx="2">
+            <a:schemeClr val="dk1"/>
+          </a:lnRef>
+          <a:fillRef idx="0">
+            <a:schemeClr val="dk1"/>
+          </a:fillRef>
+          <a:effectRef idx="1">
+            <a:schemeClr val="dk1"/>
+          </a:effectRef>
+          <a:fontRef idx="minor">
+            <a:schemeClr val="tx1"/>
+          </a:fontRef>
+        </p:style>
+        <p:txBody>
+          <a:bodyPr rtlCol="0" anchor="ctr"/>
+          <a:lstStyle/>
+          <a:p>
+            <a:pPr algn="ctr"/>
+            <a:endParaRPr lang="en-US"/>
+          </a:p>
+        </p:txBody>
+      </p:sp>
+      <p:sp>
+        <p:nvSpPr>
+          <p:cNvPr id="16" name="TextBox 15">
+            <a:extLst>
+              <a:ext uri="{FF2B5EF4-FFF2-40B4-BE49-F238E27FC236}">
+                <a16:creationId xmlns:a16="http://schemas.microsoft.com/office/drawing/2014/main" id="{ADA1AE0D-0D1D-BC9D-0313-CFFAC6BB48AE}"/>
+              </a:ext>
+            </a:extLst>
+          </p:cNvPr>
+          <p:cNvSpPr txBox="1"/>
+          <p:nvPr/>
+        </p:nvSpPr>
+        <p:spPr>
+          <a:xfrm>
+            <a:off x="10092271" y="2534768"/>
+            <a:ext cx="1370302" cy="400110"/>
+          </a:xfrm>
+          <a:prstGeom prst="rect">
+            <a:avLst/>
+          </a:prstGeom>
+          <a:noFill/>
+        </p:spPr>
+        <p:txBody>
+          <a:bodyPr wrap="square" rtlCol="0">
+            <a:spAutoFit/>
+          </a:bodyPr>
+          <a:lstStyle/>
+          <a:p>
+            <a:r>
+              <a:rPr lang="en-US" sz="2000" b="1" dirty="0"/>
+              <a:t>Outcomes</a:t>
+            </a:r>
+          </a:p>
+        </p:txBody>
+      </p:sp>
+      <p:sp>
+        <p:nvSpPr>
+          <p:cNvPr id="18" name="Right Brace 17">
+            <a:extLst>
+              <a:ext uri="{FF2B5EF4-FFF2-40B4-BE49-F238E27FC236}">
+                <a16:creationId xmlns:a16="http://schemas.microsoft.com/office/drawing/2014/main" id="{D6AD5009-AA28-5A1C-A3E8-8E080CF8B160}"/>
+              </a:ext>
+            </a:extLst>
+          </p:cNvPr>
+          <p:cNvSpPr/>
+          <p:nvPr/>
+        </p:nvSpPr>
+        <p:spPr>
+          <a:xfrm rot="16200000">
+            <a:off x="6458782" y="-692142"/>
+            <a:ext cx="584391" cy="3604350"/>
+          </a:xfrm>
+          <a:prstGeom prst="rightBrace">
+            <a:avLst>
+              <a:gd name="adj1" fmla="val 0"/>
+              <a:gd name="adj2" fmla="val 50000"/>
+            </a:avLst>
+          </a:prstGeom>
+        </p:spPr>
+        <p:style>
+          <a:lnRef idx="2">
+            <a:schemeClr val="dk1"/>
+          </a:lnRef>
+          <a:fillRef idx="0">
+            <a:schemeClr val="dk1"/>
+          </a:fillRef>
+          <a:effectRef idx="1">
+            <a:schemeClr val="dk1"/>
+          </a:effectRef>
+          <a:fontRef idx="minor">
+            <a:schemeClr val="tx1"/>
+          </a:fontRef>
+        </p:style>
+        <p:txBody>
+          <a:bodyPr rtlCol="0" anchor="ctr"/>
+          <a:lstStyle/>
+          <a:p>
+            <a:pPr algn="ctr"/>
+            <a:endParaRPr lang="en-US" dirty="0"/>
+          </a:p>
+        </p:txBody>
+      </p:sp>
+      <p:sp>
+        <p:nvSpPr>
+          <p:cNvPr id="23" name="TextBox 22">
+            <a:extLst>
+              <a:ext uri="{FF2B5EF4-FFF2-40B4-BE49-F238E27FC236}">
+                <a16:creationId xmlns:a16="http://schemas.microsoft.com/office/drawing/2014/main" id="{9DED89B0-1D70-4842-6845-4A4CA1F9C9AD}"/>
+              </a:ext>
+            </a:extLst>
+          </p:cNvPr>
+          <p:cNvSpPr txBox="1"/>
+          <p:nvPr/>
+        </p:nvSpPr>
+        <p:spPr>
+          <a:xfrm>
+            <a:off x="6151284" y="424530"/>
+            <a:ext cx="1309959" cy="400110"/>
+          </a:xfrm>
+          <a:prstGeom prst="rect">
+            <a:avLst/>
+          </a:prstGeom>
+          <a:noFill/>
+        </p:spPr>
+        <p:txBody>
+          <a:bodyPr wrap="square" rtlCol="0">
+            <a:spAutoFit/>
+          </a:bodyPr>
+          <a:lstStyle/>
+          <a:p>
+            <a:r>
+              <a:rPr lang="en-US" sz="2000" b="1" dirty="0"/>
+              <a:t>Exposures</a:t>
+            </a:r>
+            <a:endParaRPr lang="en-US" sz="1600" b="1" dirty="0"/>
           </a:p>
         </p:txBody>
       </p:sp>
@@ -3657,7 +3725,7 @@
         </p:nvSpPr>
         <p:spPr>
           <a:xfrm>
-            <a:off x="0" y="0"/>
+            <a:off x="-12882" y="0"/>
             <a:ext cx="12192000" cy="6858000"/>
           </a:xfrm>
           <a:prstGeom prst="rect">
@@ -3688,7 +3756,7 @@
         </p:nvSpPr>
         <p:spPr>
           <a:xfrm>
-            <a:off x="1265425" y="110833"/>
+            <a:off x="1043230" y="52643"/>
             <a:ext cx="7657267" cy="641201"/>
           </a:xfrm>
           <a:prstGeom prst="rect">
@@ -3744,8 +3812,8 @@
         </p:nvSpPr>
         <p:spPr>
           <a:xfrm>
-            <a:off x="767408" y="1828832"/>
-            <a:ext cx="3816424" cy="4834657"/>
+            <a:off x="949006" y="746487"/>
+            <a:ext cx="4104456" cy="4526880"/>
           </a:xfrm>
           <a:prstGeom prst="rect">
             <a:avLst/>
@@ -3778,7 +3846,7 @@
             </a:pPr>
             <a:r>
               <a:rPr lang="en-US" sz="2000" dirty="0"/>
-              <a:t>Correlation range (±0.30) expanded to reflect uncertainty for change-based effects (H1b)</a:t>
+              <a:t>Estimated using correlation-based methods</a:t>
             </a:r>
           </a:p>
           <a:p>
@@ -3795,33 +3863,58 @@
             </a:pPr>
             <a:r>
               <a:rPr lang="en-US" sz="2000" dirty="0"/>
-              <a:t>80% power at |r| ≈ 0.26–0.39</a:t>
-            </a:r>
+              <a:t>Evaluated across multiple </a:t>
+            </a:r>
+            <a:r>
+              <a:rPr lang="el-GR" sz="2000" dirty="0"/>
+              <a:t>α </a:t>
+            </a:r>
+            <a:r>
+              <a:rPr lang="en-US" sz="2000" dirty="0"/>
+              <a:t>levels</a:t>
+            </a:r>
+          </a:p>
+          <a:p>
+            <a:pPr marL="800100" lvl="1" indent="-342900">
+              <a:buFont typeface="Wingdings" pitchFamily="2" charset="2"/>
+              <a:buChar char="Ø"/>
+            </a:pPr>
+            <a:r>
+              <a:rPr lang="en-US" sz="2000" dirty="0"/>
+              <a:t>Minimal impact on choice of </a:t>
+            </a:r>
+            <a:r>
+              <a:rPr lang="el-GR" sz="2000" dirty="0"/>
+              <a:t>α</a:t>
+            </a:r>
+            <a:endParaRPr lang="en-US" sz="2000" dirty="0"/>
+          </a:p>
+          <a:p>
+            <a:pPr lvl="1"/>
+            <a:endParaRPr lang="en-US" sz="2000" dirty="0"/>
           </a:p>
           <a:p>
             <a:pPr marL="342900" indent="-342900">
               <a:buFont typeface="Wingdings" pitchFamily="2" charset="2"/>
               <a:buChar char="q"/>
             </a:pPr>
-            <a:endParaRPr lang="en-US" sz="2000" dirty="0"/>
+            <a:r>
+              <a:rPr lang="en-US" sz="2000" dirty="0"/>
+              <a:t>80% power at |r| ≈ 0.25–0.29</a:t>
+            </a:r>
           </a:p>
           <a:p>
             <a:pPr marL="342900" indent="-342900">
               <a:buFont typeface="Wingdings" pitchFamily="2" charset="2"/>
               <a:buChar char="q"/>
             </a:pPr>
-            <a:r>
-              <a:rPr lang="en-US" sz="2000" dirty="0"/>
-              <a:t>Moderate effects detectable; smaller effects may be underpowered</a:t>
-            </a:r>
-          </a:p>
-          <a:p>
-            <a:pPr marL="342900" indent="-342900">
+            <a:endParaRPr lang="en-US" sz="2000" dirty="0"/>
+          </a:p>
+          <a:p>
+            <a:pPr>
               <a:lnSpc>
                 <a:spcPts val="2258"/>
               </a:lnSpc>
-              <a:buFont typeface="Wingdings" pitchFamily="2" charset="2"/>
-              <a:buChar char="q"/>
             </a:pPr>
             <a:endParaRPr lang="en-US" sz="2000" spc="-25" dirty="0">
               <a:solidFill>
@@ -3933,10 +4026,10 @@
       </p:sp>
       <p:pic>
         <p:nvPicPr>
-          <p:cNvPr id="8" name="Picture 7">
+          <p:cNvPr id="6" name="Picture 5">
             <a:extLst>
               <a:ext uri="{FF2B5EF4-FFF2-40B4-BE49-F238E27FC236}">
-                <a16:creationId xmlns:a16="http://schemas.microsoft.com/office/drawing/2014/main" id="{9B8831E1-8361-AC85-0C71-D2645B53D5DD}"/>
+                <a16:creationId xmlns:a16="http://schemas.microsoft.com/office/drawing/2014/main" id="{39ABA57F-ED32-367D-2FBA-F0E8870CD7D0}"/>
               </a:ext>
             </a:extLst>
           </p:cNvPr>
@@ -3953,12 +4046,17 @@
         </p:blipFill>
         <p:spPr>
           <a:xfrm>
-            <a:off x="4434450" y="767677"/>
-            <a:ext cx="7684007" cy="5701302"/>
+            <a:off x="5656455" y="1162050"/>
+            <a:ext cx="5753100" cy="4533900"/>
           </a:xfrm>
           <a:prstGeom prst="rect">
             <a:avLst/>
           </a:prstGeom>
+          <a:ln>
+            <a:solidFill>
+              <a:schemeClr val="tx1"/>
+            </a:solidFill>
+          </a:ln>
         </p:spPr>
       </p:pic>
     </p:spTree>
@@ -4025,7 +4123,7 @@
         </p:nvSpPr>
         <p:spPr>
           <a:xfrm>
-            <a:off x="1415480" y="188640"/>
+            <a:off x="1016581" y="94413"/>
             <a:ext cx="4528479" cy="641201"/>
           </a:xfrm>
           <a:prstGeom prst="rect">
@@ -4386,8 +4484,8 @@
         </p:nvSpPr>
         <p:spPr>
           <a:xfrm>
-            <a:off x="867913" y="1212744"/>
-            <a:ext cx="2973409" cy="2372444"/>
+            <a:off x="804920" y="645195"/>
+            <a:ext cx="4043270" cy="3680495"/>
           </a:xfrm>
           <a:prstGeom prst="rect">
             <a:avLst/>
@@ -4399,13 +4497,74 @@
           </a:bodyPr>
           <a:lstStyle/>
           <a:p>
-            <a:pPr marL="800100" lvl="1" indent="-342900">
-              <a:lnSpc>
-                <a:spcPts val="2258"/>
-              </a:lnSpc>
+            <a:endParaRPr lang="en-US" sz="2000" dirty="0"/>
+          </a:p>
+          <a:p>
+            <a:pPr marL="342900" indent="-342900">
+              <a:buFont typeface="Wingdings" pitchFamily="2" charset="2"/>
+              <a:buChar char="q"/>
+            </a:pPr>
+            <a:r>
+              <a:rPr lang="en-US" sz="2000" dirty="0"/>
+              <a:t>Estimated using two-sample correlation method</a:t>
+            </a:r>
+          </a:p>
+          <a:p>
+            <a:pPr marL="914400" lvl="1" indent="-457200">
               <a:buFont typeface="Wingdings" pitchFamily="2" charset="2"/>
               <a:buChar char="Ø"/>
             </a:pPr>
+            <a:r>
+              <a:rPr lang="el-GR" sz="2000" dirty="0"/>
+              <a:t>α</a:t>
+            </a:r>
+            <a:r>
+              <a:rPr lang="en-US" sz="2000" dirty="0"/>
+              <a:t>=0.05/4 = 0.0125</a:t>
+            </a:r>
+          </a:p>
+          <a:p>
+            <a:pPr marL="1257300" lvl="2" indent="-342900">
+              <a:buFont typeface="Arial" panose="020B0604020202020204" pitchFamily="34" charset="0"/>
+              <a:buChar char="•"/>
+            </a:pPr>
+            <a:r>
+              <a:rPr lang="en-US" sz="2000" dirty="0"/>
+              <a:t>Per Aim 1</a:t>
+            </a:r>
+          </a:p>
+          <a:p>
+            <a:endParaRPr lang="en-US" sz="2000" dirty="0"/>
+          </a:p>
+          <a:p>
+            <a:pPr marL="342900" indent="-342900">
+              <a:buFont typeface="Wingdings" pitchFamily="2" charset="2"/>
+              <a:buChar char="q"/>
+            </a:pPr>
+            <a:r>
+              <a:rPr lang="en-US" sz="2000" dirty="0"/>
+              <a:t>Power driven more by difference between groups</a:t>
+            </a:r>
+            <a:br>
+              <a:rPr lang="en-US" sz="2000" dirty="0"/>
+            </a:br>
+            <a:endParaRPr lang="en-US" sz="2000" dirty="0"/>
+          </a:p>
+          <a:p>
+            <a:pPr marL="342900" indent="-342900">
+              <a:buFont typeface="Wingdings" pitchFamily="2" charset="2"/>
+              <a:buChar char="q"/>
+            </a:pPr>
+            <a:r>
+              <a:rPr lang="en-US" sz="2000" dirty="0"/>
+              <a:t>80% power requires:</a:t>
+            </a:r>
+          </a:p>
+          <a:p>
+            <a:r>
+              <a:rPr lang="en-US" sz="2000" dirty="0"/>
+              <a:t> |r|≈ 0.55–0.75 in Amyloid+ group</a:t>
+            </a:r>
             <a:endParaRPr lang="en-US" sz="2000" spc="-25" dirty="0">
               <a:solidFill>
                 <a:srgbClr val="181A0D"/>
@@ -4414,109 +4573,6 @@
             </a:endParaRPr>
           </a:p>
           <a:p>
-            <a:pPr marL="342900" indent="-342900">
-              <a:buFont typeface="Wingdings" pitchFamily="2" charset="2"/>
-              <a:buChar char="q"/>
-            </a:pPr>
-            <a:r>
-              <a:rPr lang="en-US" sz="2000" dirty="0"/>
-              <a:t>XXXXX</a:t>
-            </a:r>
-          </a:p>
-          <a:p>
-            <a:pPr marL="342900" indent="-342900">
-              <a:lnSpc>
-                <a:spcPts val="2258"/>
-              </a:lnSpc>
-              <a:buFont typeface="Wingdings" pitchFamily="2" charset="2"/>
-              <a:buChar char="q"/>
-            </a:pPr>
-            <a:endParaRPr lang="en-US" sz="2000" spc="-25" dirty="0">
-              <a:solidFill>
-                <a:srgbClr val="181A0D"/>
-              </a:solidFill>
-              <a:cs typeface="OAGDQN+FranklinGothic-BookItalic"/>
-            </a:endParaRPr>
-          </a:p>
-          <a:p>
-            <a:pPr marL="342900" indent="-342900">
-              <a:lnSpc>
-                <a:spcPts val="2258"/>
-              </a:lnSpc>
-              <a:buFont typeface="Wingdings" pitchFamily="2" charset="2"/>
-              <a:buChar char="Ø"/>
-            </a:pPr>
-            <a:endParaRPr lang="en-US" sz="2000" spc="-25" dirty="0">
-              <a:solidFill>
-                <a:srgbClr val="181A0D"/>
-              </a:solidFill>
-              <a:cs typeface="OAGDQN+FranklinGothic-BookItalic"/>
-            </a:endParaRPr>
-          </a:p>
-          <a:p>
-            <a:pPr marL="342900" marR="0" indent="-342900">
-              <a:lnSpc>
-                <a:spcPts val="2258"/>
-              </a:lnSpc>
-              <a:spcBef>
-                <a:spcPts val="0"/>
-              </a:spcBef>
-              <a:spcAft>
-                <a:spcPts val="0"/>
-              </a:spcAft>
-              <a:buFont typeface="Wingdings" pitchFamily="2" charset="2"/>
-              <a:buChar char="q"/>
-            </a:pPr>
-            <a:endParaRPr lang="en-US" sz="2000" spc="-25" dirty="0">
-              <a:solidFill>
-                <a:srgbClr val="181A0D"/>
-              </a:solidFill>
-              <a:cs typeface="OAGDQN+FranklinGothic-BookItalic"/>
-            </a:endParaRPr>
-          </a:p>
-          <a:p>
-            <a:pPr marL="342900" marR="0" indent="-342900">
-              <a:lnSpc>
-                <a:spcPts val="2258"/>
-              </a:lnSpc>
-              <a:spcBef>
-                <a:spcPts val="0"/>
-              </a:spcBef>
-              <a:spcAft>
-                <a:spcPts val="0"/>
-              </a:spcAft>
-              <a:buFont typeface="Wingdings" pitchFamily="2" charset="2"/>
-              <a:buChar char="q"/>
-            </a:pPr>
-            <a:endParaRPr lang="en-US" sz="2000" spc="-25" dirty="0">
-              <a:solidFill>
-                <a:srgbClr val="181A0D"/>
-              </a:solidFill>
-              <a:cs typeface="OAGDQN+FranklinGothic-BookItalic"/>
-            </a:endParaRPr>
-          </a:p>
-          <a:p>
-            <a:pPr marL="342900" marR="0" indent="-342900">
-              <a:lnSpc>
-                <a:spcPts val="2258"/>
-              </a:lnSpc>
-              <a:spcBef>
-                <a:spcPts val="0"/>
-              </a:spcBef>
-              <a:spcAft>
-                <a:spcPts val="0"/>
-              </a:spcAft>
-              <a:buFont typeface="Wingdings" pitchFamily="2" charset="2"/>
-              <a:buChar char="q"/>
-            </a:pPr>
-            <a:endParaRPr lang="en-US" sz="2000" spc="-25" dirty="0">
-              <a:solidFill>
-                <a:srgbClr val="181A0D"/>
-              </a:solidFill>
-              <a:cs typeface="OAGDQN+FranklinGothic-BookItalic"/>
-            </a:endParaRPr>
-          </a:p>
-          <a:p>
             <a:pPr marL="342900" marR="0" indent="-342900">
               <a:lnSpc>
                 <a:spcPts val="2258"/>
@@ -4539,6 +4595,306 @@
           </a:p>
         </p:txBody>
       </p:sp>
+      <p:pic>
+        <p:nvPicPr>
+          <p:cNvPr id="9" name="Picture 8">
+            <a:extLst>
+              <a:ext uri="{FF2B5EF4-FFF2-40B4-BE49-F238E27FC236}">
+                <a16:creationId xmlns:a16="http://schemas.microsoft.com/office/drawing/2014/main" id="{7B349ABF-3C8D-ABEF-6CD1-1B3F4B50A3F3}"/>
+              </a:ext>
+            </a:extLst>
+          </p:cNvPr>
+          <p:cNvPicPr>
+            <a:picLocks noChangeAspect="1"/>
+          </p:cNvPicPr>
+          <p:nvPr/>
+        </p:nvPicPr>
+        <p:blipFill>
+          <a:blip r:embed="rId4"/>
+          <a:stretch>
+            <a:fillRect/>
+          </a:stretch>
+        </p:blipFill>
+        <p:spPr>
+          <a:xfrm>
+            <a:off x="4655840" y="815861"/>
+            <a:ext cx="7392398" cy="5131912"/>
+          </a:xfrm>
+          <a:prstGeom prst="rect">
+            <a:avLst/>
+          </a:prstGeom>
+          <a:ln>
+            <a:solidFill>
+              <a:schemeClr val="tx1"/>
+            </a:solidFill>
+          </a:ln>
+        </p:spPr>
+      </p:pic>
+      <p:sp>
+        <p:nvSpPr>
+          <p:cNvPr id="10" name="Rectangle 9">
+            <a:extLst>
+              <a:ext uri="{FF2B5EF4-FFF2-40B4-BE49-F238E27FC236}">
+                <a16:creationId xmlns:a16="http://schemas.microsoft.com/office/drawing/2014/main" id="{527E5FBF-CC88-D168-7F28-F4BDC8D08F05}"/>
+              </a:ext>
+            </a:extLst>
+          </p:cNvPr>
+          <p:cNvSpPr/>
+          <p:nvPr/>
+        </p:nvSpPr>
+        <p:spPr>
+          <a:xfrm>
+            <a:off x="5303912" y="3861048"/>
+            <a:ext cx="648072" cy="216024"/>
+          </a:xfrm>
+          <a:prstGeom prst="rect">
+            <a:avLst/>
+          </a:prstGeom>
+          <a:noFill/>
+          <a:ln>
+            <a:solidFill>
+              <a:schemeClr val="accent2"/>
+            </a:solidFill>
+          </a:ln>
+        </p:spPr>
+        <p:style>
+          <a:lnRef idx="2">
+            <a:schemeClr val="accent1">
+              <a:shade val="15000"/>
+            </a:schemeClr>
+          </a:lnRef>
+          <a:fillRef idx="1">
+            <a:schemeClr val="accent1"/>
+          </a:fillRef>
+          <a:effectRef idx="0">
+            <a:schemeClr val="accent1"/>
+          </a:effectRef>
+          <a:fontRef idx="minor">
+            <a:schemeClr val="lt1"/>
+          </a:fontRef>
+        </p:style>
+        <p:txBody>
+          <a:bodyPr rtlCol="0" anchor="ctr"/>
+          <a:lstStyle/>
+          <a:p>
+            <a:pPr algn="ctr"/>
+            <a:endParaRPr lang="en-US"/>
+          </a:p>
+        </p:txBody>
+      </p:sp>
+      <p:sp>
+        <p:nvSpPr>
+          <p:cNvPr id="11" name="TextBox 10">
+            <a:extLst>
+              <a:ext uri="{FF2B5EF4-FFF2-40B4-BE49-F238E27FC236}">
+                <a16:creationId xmlns:a16="http://schemas.microsoft.com/office/drawing/2014/main" id="{B23582D8-D35D-ECF5-07C1-BF6C945C3F81}"/>
+              </a:ext>
+            </a:extLst>
+          </p:cNvPr>
+          <p:cNvSpPr txBox="1"/>
+          <p:nvPr/>
+        </p:nvSpPr>
+        <p:spPr>
+          <a:xfrm>
+            <a:off x="6270570" y="4464070"/>
+            <a:ext cx="1152128" cy="276999"/>
+          </a:xfrm>
+          <a:prstGeom prst="rect">
+            <a:avLst/>
+          </a:prstGeom>
+          <a:noFill/>
+        </p:spPr>
+        <p:txBody>
+          <a:bodyPr wrap="square" rtlCol="0">
+            <a:spAutoFit/>
+          </a:bodyPr>
+          <a:lstStyle/>
+          <a:p>
+            <a:r>
+              <a:rPr lang="en-US" sz="1200" dirty="0">
+                <a:solidFill>
+                  <a:schemeClr val="accent2"/>
+                </a:solidFill>
+              </a:rPr>
+              <a:t>Most favorable</a:t>
+            </a:r>
+          </a:p>
+        </p:txBody>
+      </p:sp>
+      <p:cxnSp>
+        <p:nvCxnSpPr>
+          <p:cNvPr id="13" name="Straight Arrow Connector 12">
+            <a:extLst>
+              <a:ext uri="{FF2B5EF4-FFF2-40B4-BE49-F238E27FC236}">
+                <a16:creationId xmlns:a16="http://schemas.microsoft.com/office/drawing/2014/main" id="{8BC95CEA-A05C-18DB-941F-1EE8A6F5508C}"/>
+              </a:ext>
+            </a:extLst>
+          </p:cNvPr>
+          <p:cNvCxnSpPr>
+            <a:cxnSpLocks/>
+            <a:stCxn id="11" idx="1"/>
+          </p:cNvCxnSpPr>
+          <p:nvPr/>
+        </p:nvCxnSpPr>
+        <p:spPr>
+          <a:xfrm flipH="1" flipV="1">
+            <a:off x="5742526" y="4157319"/>
+            <a:ext cx="528044" cy="445251"/>
+          </a:xfrm>
+          <a:prstGeom prst="straightConnector1">
+            <a:avLst/>
+          </a:prstGeom>
+          <a:ln>
+            <a:tailEnd type="triangle"/>
+          </a:ln>
+        </p:spPr>
+        <p:style>
+          <a:lnRef idx="1">
+            <a:schemeClr val="accent2"/>
+          </a:lnRef>
+          <a:fillRef idx="0">
+            <a:schemeClr val="accent2"/>
+          </a:fillRef>
+          <a:effectRef idx="0">
+            <a:schemeClr val="accent2"/>
+          </a:effectRef>
+          <a:fontRef idx="minor">
+            <a:schemeClr val="tx1"/>
+          </a:fontRef>
+        </p:style>
+      </p:cxnSp>
+      <p:sp>
+        <p:nvSpPr>
+          <p:cNvPr id="18" name="Rectangle 17">
+            <a:extLst>
+              <a:ext uri="{FF2B5EF4-FFF2-40B4-BE49-F238E27FC236}">
+                <a16:creationId xmlns:a16="http://schemas.microsoft.com/office/drawing/2014/main" id="{26D0FE2F-AA88-B0DE-6C64-6D569E360815}"/>
+              </a:ext>
+            </a:extLst>
+          </p:cNvPr>
+          <p:cNvSpPr/>
+          <p:nvPr/>
+        </p:nvSpPr>
+        <p:spPr>
+          <a:xfrm>
+            <a:off x="9984432" y="3212976"/>
+            <a:ext cx="576064" cy="216024"/>
+          </a:xfrm>
+          <a:prstGeom prst="rect">
+            <a:avLst/>
+          </a:prstGeom>
+          <a:noFill/>
+          <a:ln>
+            <a:solidFill>
+              <a:schemeClr val="accent2"/>
+            </a:solidFill>
+          </a:ln>
+        </p:spPr>
+        <p:style>
+          <a:lnRef idx="2">
+            <a:schemeClr val="accent1">
+              <a:shade val="15000"/>
+            </a:schemeClr>
+          </a:lnRef>
+          <a:fillRef idx="1">
+            <a:schemeClr val="accent1"/>
+          </a:fillRef>
+          <a:effectRef idx="0">
+            <a:schemeClr val="accent1"/>
+          </a:effectRef>
+          <a:fontRef idx="minor">
+            <a:schemeClr val="lt1"/>
+          </a:fontRef>
+        </p:style>
+        <p:txBody>
+          <a:bodyPr rtlCol="0" anchor="ctr"/>
+          <a:lstStyle/>
+          <a:p>
+            <a:pPr algn="ctr"/>
+            <a:endParaRPr lang="en-US"/>
+          </a:p>
+        </p:txBody>
+      </p:sp>
+      <p:sp>
+        <p:nvSpPr>
+          <p:cNvPr id="19" name="TextBox 18">
+            <a:extLst>
+              <a:ext uri="{FF2B5EF4-FFF2-40B4-BE49-F238E27FC236}">
+                <a16:creationId xmlns:a16="http://schemas.microsoft.com/office/drawing/2014/main" id="{576A98FC-2BC9-9113-BB32-489E7A04C0D9}"/>
+              </a:ext>
+            </a:extLst>
+          </p:cNvPr>
+          <p:cNvSpPr txBox="1"/>
+          <p:nvPr/>
+        </p:nvSpPr>
+        <p:spPr>
+          <a:xfrm>
+            <a:off x="10001725" y="2535129"/>
+            <a:ext cx="1152128" cy="276999"/>
+          </a:xfrm>
+          <a:prstGeom prst="rect">
+            <a:avLst/>
+          </a:prstGeom>
+          <a:noFill/>
+        </p:spPr>
+        <p:txBody>
+          <a:bodyPr wrap="square" rtlCol="0">
+            <a:spAutoFit/>
+          </a:bodyPr>
+          <a:lstStyle/>
+          <a:p>
+            <a:r>
+              <a:rPr lang="en-US" sz="1200" dirty="0">
+                <a:solidFill>
+                  <a:schemeClr val="accent2"/>
+                </a:solidFill>
+              </a:rPr>
+              <a:t>Least favorable</a:t>
+            </a:r>
+          </a:p>
+        </p:txBody>
+      </p:sp>
+      <p:cxnSp>
+        <p:nvCxnSpPr>
+          <p:cNvPr id="20" name="Straight Arrow Connector 19">
+            <a:extLst>
+              <a:ext uri="{FF2B5EF4-FFF2-40B4-BE49-F238E27FC236}">
+                <a16:creationId xmlns:a16="http://schemas.microsoft.com/office/drawing/2014/main" id="{C53275D0-CDC3-A452-C71C-40A9D05171E4}"/>
+              </a:ext>
+            </a:extLst>
+          </p:cNvPr>
+          <p:cNvCxnSpPr>
+            <a:cxnSpLocks/>
+          </p:cNvCxnSpPr>
+          <p:nvPr/>
+        </p:nvCxnSpPr>
+        <p:spPr>
+          <a:xfrm flipH="1">
+            <a:off x="10272464" y="2812128"/>
+            <a:ext cx="240012" cy="380795"/>
+          </a:xfrm>
+          <a:prstGeom prst="straightConnector1">
+            <a:avLst/>
+          </a:prstGeom>
+          <a:ln>
+            <a:tailEnd type="triangle"/>
+          </a:ln>
+        </p:spPr>
+        <p:style>
+          <a:lnRef idx="1">
+            <a:schemeClr val="accent2"/>
+          </a:lnRef>
+          <a:fillRef idx="0">
+            <a:schemeClr val="accent2"/>
+          </a:fillRef>
+          <a:effectRef idx="0">
+            <a:schemeClr val="accent2"/>
+          </a:effectRef>
+          <a:fontRef idx="minor">
+            <a:schemeClr val="tx1"/>
+          </a:fontRef>
+        </p:style>
+      </p:cxnSp>
     </p:spTree>
   </p:cSld>
   <p:clrMapOvr>
@@ -4603,7 +4959,7 @@
         </p:nvSpPr>
         <p:spPr>
           <a:xfrm>
-            <a:off x="1343472" y="260648"/>
+            <a:off x="1109484" y="156617"/>
             <a:ext cx="2704871" cy="641201"/>
           </a:xfrm>
           <a:prstGeom prst="rect">
@@ -4659,8 +5015,8 @@
         </p:nvSpPr>
         <p:spPr>
           <a:xfrm>
-            <a:off x="1127448" y="1132209"/>
-            <a:ext cx="10297144" cy="4716676"/>
+            <a:off x="1109484" y="864195"/>
+            <a:ext cx="10297144" cy="5129609"/>
           </a:xfrm>
           <a:prstGeom prst="rect">
             <a:avLst/>
@@ -4671,6 +5027,10 @@
             <a:spAutoFit/>
           </a:bodyPr>
           <a:lstStyle/>
+          <a:p>
+            <a:pPr lvl="1"/>
+            <a:endParaRPr lang="en-US" sz="2000" dirty="0"/>
+          </a:p>
           <a:p>
             <a:pPr marL="342900" indent="-342900">
               <a:lnSpc>
@@ -4684,40 +5044,40 @@
                 <a:solidFill>
                   <a:srgbClr val="181A0D"/>
                 </a:solidFill>
-                <a:cs typeface="OAGDQN+FranklinGothic-BookItalic"/>
               </a:rPr>
-              <a:t>Expectations:</a:t>
-            </a:r>
-          </a:p>
-          <a:p>
-            <a:pPr marL="742950" lvl="1" indent="-285750">
+              <a:t>Power:</a:t>
+            </a:r>
+          </a:p>
+          <a:p>
+            <a:pPr marL="800100" lvl="1" indent="-342900">
               <a:buFont typeface="Wingdings" pitchFamily="2" charset="2"/>
               <a:buChar char="Ø"/>
             </a:pPr>
             <a:r>
-              <a:rPr lang="en-US" dirty="0"/>
-              <a:t>Inflammation associated with cognitive decline</a:t>
-            </a:r>
-          </a:p>
-          <a:p>
-            <a:pPr marL="742950" lvl="1" indent="-285750">
+              <a:rPr lang="en-US" sz="2000" dirty="0"/>
+              <a:t>Aim 1: Moderate effects detectable</a:t>
+            </a:r>
+          </a:p>
+          <a:p>
+            <a:pPr marL="800100" lvl="1" indent="-342900">
               <a:buFont typeface="Wingdings" pitchFamily="2" charset="2"/>
               <a:buChar char="Ø"/>
             </a:pPr>
             <a:r>
-              <a:rPr lang="en-US" dirty="0"/>
-              <a:t>Stronger effects for cortical thickness</a:t>
-            </a:r>
-          </a:p>
-          <a:p>
-            <a:pPr marL="742950" lvl="1" indent="-285750">
-              <a:buFont typeface="Wingdings" pitchFamily="2" charset="2"/>
-              <a:buChar char="Ø"/>
-            </a:pPr>
-            <a:r>
-              <a:rPr lang="en-US" dirty="0"/>
-              <a:t>Amyloid modifies inflammation–outcome relationship</a:t>
-            </a:r>
+              <a:rPr lang="en-US" sz="2000" dirty="0"/>
+              <a:t>Aim 2: Moderate-to-large interactions detectable</a:t>
+            </a:r>
+          </a:p>
+          <a:p>
+            <a:pPr lvl="1"/>
+            <a:endParaRPr lang="en-US" sz="2000" dirty="0"/>
+          </a:p>
+          <a:p>
+            <a:pPr>
+              <a:lnSpc>
+                <a:spcPts val="2258"/>
+              </a:lnSpc>
+            </a:pPr>
             <a:endParaRPr lang="en-US" sz="2000" spc="-25" dirty="0">
               <a:solidFill>
                 <a:srgbClr val="181A0D"/>
@@ -4727,6 +5087,51 @@
           </a:p>
           <a:p>
             <a:pPr marL="342900" indent="-342900">
+              <a:buFont typeface="Wingdings" pitchFamily="2" charset="2"/>
+              <a:buChar char="q"/>
+            </a:pPr>
+            <a:r>
+              <a:rPr lang="en-US" sz="2000" b="1" dirty="0"/>
+              <a:t>Limitations:</a:t>
+            </a:r>
+            <a:endParaRPr lang="en-US" sz="2000" dirty="0"/>
+          </a:p>
+          <a:p>
+            <a:pPr marL="800100" lvl="1" indent="-342900">
+              <a:buFont typeface="Wingdings" pitchFamily="2" charset="2"/>
+              <a:buChar char="Ø"/>
+            </a:pPr>
+            <a:r>
+              <a:rPr lang="en-US" sz="2000" dirty="0"/>
+              <a:t>Limited power for small effects</a:t>
+            </a:r>
+          </a:p>
+          <a:p>
+            <a:pPr marL="800100" lvl="1" indent="-342900">
+              <a:buFont typeface="Wingdings" pitchFamily="2" charset="2"/>
+              <a:buChar char="Ø"/>
+            </a:pPr>
+            <a:r>
+              <a:rPr lang="en-US" sz="2000" dirty="0"/>
+              <a:t>Interaction effects harder to detect</a:t>
+            </a:r>
+          </a:p>
+          <a:p>
+            <a:pPr marL="800100" lvl="1" indent="-342900">
+              <a:buFont typeface="Wingdings" pitchFamily="2" charset="2"/>
+              <a:buChar char="Ø"/>
+            </a:pPr>
+            <a:r>
+              <a:rPr lang="en-US" sz="2000" dirty="0"/>
+              <a:t>Sample size is likely too small</a:t>
+            </a:r>
+          </a:p>
+          <a:p>
+            <a:pPr lvl="1"/>
+            <a:endParaRPr lang="en-US" sz="2000" dirty="0"/>
+          </a:p>
+          <a:p>
+            <a:pPr marL="342900" indent="-342900">
               <a:lnSpc>
                 <a:spcPts val="2258"/>
               </a:lnSpc>
@@ -4756,51 +5161,16 @@
             </a:endParaRPr>
           </a:p>
           <a:p>
-            <a:pPr marL="342900" indent="-342900">
-              <a:buFont typeface="Wingdings" pitchFamily="2" charset="2"/>
-              <a:buChar char="q"/>
-            </a:pPr>
-            <a:r>
-              <a:rPr lang="en-US" sz="2000" b="1" dirty="0"/>
-              <a:t>Limitations:</a:t>
-            </a:r>
-            <a:endParaRPr lang="en-US" sz="2000" dirty="0"/>
-          </a:p>
-          <a:p>
-            <a:pPr marL="800100" lvl="1" indent="-342900">
-              <a:buFont typeface="Wingdings" pitchFamily="2" charset="2"/>
-              <a:buChar char="Ø"/>
-            </a:pPr>
-            <a:r>
-              <a:rPr lang="en-US" sz="2000" dirty="0"/>
-              <a:t>Small sample size (N=175)</a:t>
-            </a:r>
-          </a:p>
-          <a:p>
-            <a:pPr marL="800100" lvl="1" indent="-342900">
-              <a:buFont typeface="Wingdings" pitchFamily="2" charset="2"/>
-              <a:buChar char="Ø"/>
-            </a:pPr>
-            <a:r>
-              <a:rPr lang="en-US" sz="2000" dirty="0"/>
-              <a:t>Limited power for small effects</a:t>
-            </a:r>
-          </a:p>
-          <a:p>
-            <a:pPr marL="800100" lvl="1" indent="-342900">
-              <a:buFont typeface="Wingdings" pitchFamily="2" charset="2"/>
-              <a:buChar char="Ø"/>
-            </a:pPr>
-            <a:r>
-              <a:rPr lang="en-US" sz="2000" dirty="0"/>
-              <a:t>Interaction effects harder to detect</a:t>
-            </a:r>
-          </a:p>
-          <a:p>
-            <a:pPr marL="342900" indent="-342900">
+            <a:pPr marL="342900" marR="0" indent="-342900">
               <a:lnSpc>
                 <a:spcPts val="2258"/>
               </a:lnSpc>
+              <a:spcBef>
+                <a:spcPts val="0"/>
+              </a:spcBef>
+              <a:spcAft>
+                <a:spcPts val="0"/>
+              </a:spcAft>
               <a:buFont typeface="Wingdings" pitchFamily="2" charset="2"/>
               <a:buChar char="q"/>
             </a:pPr>
@@ -4812,10 +5182,16 @@
             </a:endParaRPr>
           </a:p>
           <a:p>
-            <a:pPr marL="342900" indent="-342900">
+            <a:pPr marL="342900" marR="0" indent="-342900">
               <a:lnSpc>
                 <a:spcPts val="2258"/>
               </a:lnSpc>
+              <a:spcBef>
+                <a:spcPts val="0"/>
+              </a:spcBef>
+              <a:spcAft>
+                <a:spcPts val="0"/>
+              </a:spcAft>
               <a:buFont typeface="Wingdings" pitchFamily="2" charset="2"/>
               <a:buChar char="q"/>
             </a:pPr>
@@ -4861,48 +5237,6 @@
               <a:buFont typeface="Wingdings" pitchFamily="2" charset="2"/>
               <a:buChar char="q"/>
             </a:pPr>
-            <a:endParaRPr lang="en-US" sz="2000" spc="-25" dirty="0">
-              <a:solidFill>
-                <a:srgbClr val="181A0D"/>
-              </a:solidFill>
-              <a:cs typeface="OAGDQN+FranklinGothic-BookItalic"/>
-            </a:endParaRPr>
-          </a:p>
-          <a:p>
-            <a:pPr marL="342900" marR="0" indent="-342900">
-              <a:lnSpc>
-                <a:spcPts val="2258"/>
-              </a:lnSpc>
-              <a:spcBef>
-                <a:spcPts val="0"/>
-              </a:spcBef>
-              <a:spcAft>
-                <a:spcPts val="0"/>
-              </a:spcAft>
-              <a:buFont typeface="Wingdings" pitchFamily="2" charset="2"/>
-              <a:buChar char="q"/>
-            </a:pPr>
-            <a:endParaRPr lang="en-US" sz="2000" spc="-25" dirty="0">
-              <a:solidFill>
-                <a:srgbClr val="181A0D"/>
-              </a:solidFill>
-              <a:cs typeface="OAGDQN+FranklinGothic-BookItalic"/>
-            </a:endParaRPr>
-          </a:p>
-          <a:p>
-            <a:pPr marL="342900" marR="0" indent="-342900">
-              <a:lnSpc>
-                <a:spcPts val="2258"/>
-              </a:lnSpc>
-              <a:spcBef>
-                <a:spcPts val="0"/>
-              </a:spcBef>
-              <a:spcAft>
-                <a:spcPts val="0"/>
-              </a:spcAft>
-              <a:buFont typeface="Wingdings" pitchFamily="2" charset="2"/>
-              <a:buChar char="q"/>
-            </a:pPr>
             <a:endParaRPr sz="2000" spc="-25" dirty="0">
               <a:solidFill>
                 <a:srgbClr val="181A0D"/>
@@ -4912,344 +5246,6 @@
           </a:p>
         </p:txBody>
       </p:sp>
-    </p:spTree>
-  </p:cSld>
-  <p:clrMapOvr>
-    <a:masterClrMapping/>
-  </p:clrMapOvr>
-</p:sld>
-</file>
-
-<file path=ppt/slides/slide7.xml><?xml version="1.0" encoding="utf-8"?>
-<p:sld xmlns:a="http://schemas.openxmlformats.org/drawingml/2006/main" xmlns:r="http://schemas.openxmlformats.org/officeDocument/2006/relationships" xmlns:p="http://schemas.openxmlformats.org/presentationml/2006/main" showMasterSp="0">
-  <p:cSld>
-    <p:spTree>
-      <p:nvGrpSpPr>
-        <p:cNvPr id="1" name=""/>
-        <p:cNvGrpSpPr/>
-        <p:nvPr/>
-      </p:nvGrpSpPr>
-      <p:grpSpPr>
-        <a:xfrm>
-          <a:off x="0" y="0"/>
-          <a:ext cx="0" cy="0"/>
-          <a:chOff x="0" y="0"/>
-          <a:chExt cx="0" cy="0"/>
-        </a:xfrm>
-      </p:grpSpPr>
-      <p:sp>
-        <p:nvSpPr>
-          <p:cNvPr id="2" name="object 1"/>
-          <p:cNvSpPr/>
-          <p:nvPr/>
-        </p:nvSpPr>
-        <p:spPr>
-          <a:xfrm>
-            <a:off x="0" y="0"/>
-            <a:ext cx="12192000" cy="6858000"/>
-          </a:xfrm>
-          <a:prstGeom prst="rect">
-            <a:avLst/>
-          </a:prstGeom>
-          <a:blipFill>
-            <a:blip r:embed="rId3" cstate="print"/>
-            <a:stretch>
-              <a:fillRect/>
-            </a:stretch>
-          </a:blipFill>
-        </p:spPr>
-        <p:txBody>
-          <a:bodyPr wrap="square" lIns="0" tIns="0" rIns="0" bIns="0" rtlCol="0">
-            <a:spAutoFit/>
-          </a:bodyPr>
-          <a:lstStyle/>
-          <a:p>
-            <a:endParaRPr dirty="0"/>
-          </a:p>
-        </p:txBody>
-      </p:sp>
-      <p:sp>
-        <p:nvSpPr>
-          <p:cNvPr id="3" name="object 3"/>
-          <p:cNvSpPr txBox="1"/>
-          <p:nvPr/>
-        </p:nvSpPr>
-        <p:spPr>
-          <a:xfrm>
-            <a:off x="1199456" y="133760"/>
-            <a:ext cx="5976664" cy="641201"/>
-          </a:xfrm>
-          <a:prstGeom prst="rect">
-            <a:avLst/>
-          </a:prstGeom>
-        </p:spPr>
-        <p:txBody>
-          <a:bodyPr vert="horz" wrap="square" lIns="0" tIns="0" rIns="0" bIns="0" rtlCol="0">
-            <a:spAutoFit/>
-          </a:bodyPr>
-          <a:lstStyle/>
-          <a:p>
-            <a:pPr marL="0" marR="0">
-              <a:lnSpc>
-                <a:spcPts val="4979"/>
-              </a:lnSpc>
-              <a:spcBef>
-                <a:spcPts val="0"/>
-              </a:spcBef>
-              <a:spcAft>
-                <a:spcPts val="0"/>
-              </a:spcAft>
-            </a:pPr>
-            <a:r>
-              <a:rPr lang="en-US" sz="4400" spc="-19" dirty="0">
-                <a:solidFill>
-                  <a:srgbClr val="181A0D"/>
-                </a:solidFill>
-                <a:cs typeface="NOOILK+FranklinGothic-Book"/>
-              </a:rPr>
-              <a:t>Outcomes &amp; Exposures</a:t>
-            </a:r>
-            <a:endParaRPr sz="4400" spc="-19" dirty="0">
-              <a:solidFill>
-                <a:srgbClr val="181A0D"/>
-              </a:solidFill>
-              <a:cs typeface="NOOILK+FranklinGothic-Book"/>
-            </a:endParaRPr>
-          </a:p>
-        </p:txBody>
-      </p:sp>
-      <p:sp>
-        <p:nvSpPr>
-          <p:cNvPr id="13" name="TextBox 12">
-            <a:extLst>
-              <a:ext uri="{FF2B5EF4-FFF2-40B4-BE49-F238E27FC236}">
-                <a16:creationId xmlns:a16="http://schemas.microsoft.com/office/drawing/2014/main" id="{2F490F4B-F9EE-36A8-DC87-2A09F4C4F2EF}"/>
-              </a:ext>
-            </a:extLst>
-          </p:cNvPr>
-          <p:cNvSpPr txBox="1"/>
-          <p:nvPr/>
-        </p:nvSpPr>
-        <p:spPr>
-          <a:xfrm>
-            <a:off x="839416" y="1124744"/>
-            <a:ext cx="8185212" cy="4095993"/>
-          </a:xfrm>
-          <a:prstGeom prst="rect">
-            <a:avLst/>
-          </a:prstGeom>
-          <a:noFill/>
-        </p:spPr>
-        <p:txBody>
-          <a:bodyPr wrap="square">
-            <a:spAutoFit/>
-          </a:bodyPr>
-          <a:lstStyle/>
-          <a:p>
-            <a:pPr>
-              <a:lnSpc>
-                <a:spcPts val="2258"/>
-              </a:lnSpc>
-            </a:pPr>
-            <a:r>
-              <a:rPr lang="en-US" b="1" dirty="0">
-                <a:solidFill>
-                  <a:srgbClr val="181A0D"/>
-                </a:solidFill>
-              </a:rPr>
-              <a:t>Outcomes (1-yr </a:t>
-            </a:r>
-            <a:r>
-              <a:rPr lang="el-GR" b="1" dirty="0">
-                <a:solidFill>
-                  <a:srgbClr val="181A0D"/>
-                </a:solidFill>
-              </a:rPr>
-              <a:t>Δ</a:t>
-            </a:r>
-            <a:r>
-              <a:rPr lang="en-US" b="1" dirty="0">
-                <a:solidFill>
-                  <a:srgbClr val="181A0D"/>
-                </a:solidFill>
-              </a:rPr>
-              <a:t>; baseline-1-yr</a:t>
-            </a:r>
-            <a:r>
-              <a:rPr lang="el-GR" b="1" dirty="0">
-                <a:solidFill>
-                  <a:srgbClr val="181A0D"/>
-                </a:solidFill>
-              </a:rPr>
-              <a:t>)</a:t>
-            </a:r>
-            <a:r>
-              <a:rPr lang="en-US" b="1" dirty="0">
-                <a:solidFill>
-                  <a:srgbClr val="181A0D"/>
-                </a:solidFill>
-              </a:rPr>
-              <a:t>:</a:t>
-            </a:r>
-          </a:p>
-          <a:p>
-            <a:pPr marL="285750" indent="-285750">
-              <a:buFont typeface="Wingdings" pitchFamily="2" charset="2"/>
-              <a:buChar char="q"/>
-            </a:pPr>
-            <a:r>
-              <a:rPr lang="en-US" dirty="0"/>
-              <a:t>Cognitive: CVLT, Benson, MST, Store Recall</a:t>
-            </a:r>
-          </a:p>
-          <a:p>
-            <a:pPr marL="285750" indent="-285750">
-              <a:buFont typeface="Wingdings" pitchFamily="2" charset="2"/>
-              <a:buChar char="q"/>
-            </a:pPr>
-            <a:r>
-              <a:rPr lang="en-US" dirty="0"/>
-              <a:t>Brain structure: cortical thickness</a:t>
-            </a:r>
-          </a:p>
-          <a:p>
-            <a:pPr lvl="1">
-              <a:lnSpc>
-                <a:spcPts val="2258"/>
-              </a:lnSpc>
-            </a:pPr>
-            <a:endParaRPr lang="en-US" dirty="0">
-              <a:solidFill>
-                <a:srgbClr val="181A0D"/>
-              </a:solidFill>
-            </a:endParaRPr>
-          </a:p>
-          <a:p>
-            <a:r>
-              <a:rPr lang="en-US" b="1" dirty="0"/>
-              <a:t>Exposures:</a:t>
-            </a:r>
-            <a:endParaRPr lang="en-US" dirty="0"/>
-          </a:p>
-          <a:p>
-            <a:pPr marL="285750" indent="-285750">
-              <a:buFont typeface="Wingdings" pitchFamily="2" charset="2"/>
-              <a:buChar char="q"/>
-            </a:pPr>
-            <a:r>
-              <a:rPr lang="en-US" dirty="0"/>
-              <a:t>Baseline inflammation (IL-6, TNF-</a:t>
-            </a:r>
-            <a:r>
-              <a:rPr lang="el-GR" dirty="0"/>
-              <a:t>α, </a:t>
-            </a:r>
-            <a:r>
-              <a:rPr lang="en-US" dirty="0"/>
-              <a:t>MCP-1, Eotaxin-1)</a:t>
-            </a:r>
-          </a:p>
-          <a:p>
-            <a:pPr marL="285750" indent="-285750">
-              <a:buFont typeface="Wingdings" pitchFamily="2" charset="2"/>
-              <a:buChar char="q"/>
-            </a:pPr>
-            <a:r>
-              <a:rPr lang="en-US" dirty="0"/>
-              <a:t>Change in inflammation (baseline → 1 year)</a:t>
-            </a:r>
-          </a:p>
-          <a:p>
-            <a:pPr marL="285750" indent="-285750">
-              <a:buFont typeface="Wingdings" pitchFamily="2" charset="2"/>
-              <a:buChar char="q"/>
-            </a:pPr>
-            <a:r>
-              <a:rPr lang="en-US" dirty="0"/>
-              <a:t>Baseline amyloid (binary) * baseline inflammation (continuous)</a:t>
-            </a:r>
-          </a:p>
-          <a:p>
-            <a:pPr lvl="1">
-              <a:lnSpc>
-                <a:spcPts val="2258"/>
-              </a:lnSpc>
-            </a:pPr>
-            <a:endParaRPr lang="en-US" dirty="0">
-              <a:solidFill>
-                <a:srgbClr val="181A0D"/>
-              </a:solidFill>
-              <a:cs typeface="OAGDQN+FranklinGothic-BookItalic"/>
-            </a:endParaRPr>
-          </a:p>
-          <a:p>
-            <a:pPr marL="742950" lvl="1" indent="-285750">
-              <a:buFont typeface="Wingdings" pitchFamily="2" charset="2"/>
-              <a:buChar char="Ø"/>
-            </a:pPr>
-            <a:endParaRPr lang="en-US" dirty="0"/>
-          </a:p>
-          <a:p>
-            <a:pPr marL="285750" indent="-285750">
-              <a:buFont typeface="Wingdings" pitchFamily="2" charset="2"/>
-              <a:buChar char="Ø"/>
-            </a:pPr>
-            <a:endParaRPr lang="en-US" dirty="0"/>
-          </a:p>
-          <a:p>
-            <a:pPr marL="285750" indent="-285750">
-              <a:buFont typeface="Wingdings" pitchFamily="2" charset="2"/>
-              <a:buChar char="Ø"/>
-            </a:pPr>
-            <a:endParaRPr lang="en-US" dirty="0"/>
-          </a:p>
-          <a:p>
-            <a:endParaRPr lang="en-US" dirty="0">
-              <a:solidFill>
-                <a:srgbClr val="181A0D"/>
-              </a:solidFill>
-              <a:cs typeface="OAGDQN+FranklinGothic-BookItalic"/>
-            </a:endParaRPr>
-          </a:p>
-          <a:p>
-            <a:pPr marL="285750" indent="-285750">
-              <a:buFont typeface="Wingdings" pitchFamily="2" charset="2"/>
-              <a:buChar char="§"/>
-            </a:pPr>
-            <a:endParaRPr lang="en-US" dirty="0"/>
-          </a:p>
-        </p:txBody>
-      </p:sp>
-      <p:pic>
-        <p:nvPicPr>
-          <p:cNvPr id="4" name="Picture 3">
-            <a:extLst>
-              <a:ext uri="{FF2B5EF4-FFF2-40B4-BE49-F238E27FC236}">
-                <a16:creationId xmlns:a16="http://schemas.microsoft.com/office/drawing/2014/main" id="{046C5995-99E2-2284-2E76-90B693ED756A}"/>
-              </a:ext>
-            </a:extLst>
-          </p:cNvPr>
-          <p:cNvPicPr>
-            <a:picLocks noChangeAspect="1"/>
-          </p:cNvPicPr>
-          <p:nvPr/>
-        </p:nvPicPr>
-        <p:blipFill>
-          <a:blip r:embed="rId4"/>
-          <a:stretch>
-            <a:fillRect/>
-          </a:stretch>
-        </p:blipFill>
-        <p:spPr>
-          <a:xfrm>
-            <a:off x="1847528" y="3573016"/>
-            <a:ext cx="9008325" cy="2886249"/>
-          </a:xfrm>
-          <a:prstGeom prst="rect">
-            <a:avLst/>
-          </a:prstGeom>
-        </p:spPr>
-      </p:pic>
     </p:spTree>
   </p:cSld>
   <p:clrMapOvr>

</xml_diff>

<commit_message>
added project 3 materials
</commit_message>
<xml_diff>
--- a/Project2/Reports/Project2_Presentation_summers.pptx
+++ b/Project2/Reports/Project2_Presentation_summers.pptx
@@ -19,7 +19,7 @@
   <p:notesSz cx="12192000" cy="6858000"/>
   <p:embeddedFontLst>
     <p:embeddedFont>
-      <p:font typeface="GEHAIV+FranklinGothic-Book" panose="02000500000000000000" pitchFamily="2" charset="0"/>
+      <p:font typeface="GEHAIV+FranklinGothic-Book" panose="02000500000000000000"/>
       <p:regular r:id="rId9"/>
     </p:embeddedFont>
     <p:embeddedFont>
@@ -27,7 +27,7 @@
       <p:regular r:id="rId10"/>
     </p:embeddedFont>
     <p:embeddedFont>
-      <p:font typeface="LVLFDH+FranklinGothic-Book" panose="02000500000000000000" pitchFamily="2" charset="0"/>
+      <p:font typeface="LVLFDH+FranklinGothic-Book" panose="02000500000000000000"/>
       <p:regular r:id="rId11"/>
     </p:embeddedFont>
     <p:embeddedFont>
@@ -35,15 +35,15 @@
       <p:regular r:id="rId12"/>
     </p:embeddedFont>
     <p:embeddedFont>
-      <p:font typeface="OAGDQN+FranklinGothic-BookItalic" panose="02000500000000000000" pitchFamily="2" charset="0"/>
+      <p:font typeface="OAGDQN+FranklinGothic-BookItalic" panose="02000500000000000000"/>
       <p:regular r:id="rId13"/>
     </p:embeddedFont>
     <p:embeddedFont>
-      <p:font typeface="VTCKGD+FranklinGothic-Book" panose="02000500000000000000" pitchFamily="2" charset="0"/>
+      <p:font typeface="VTCKGD+FranklinGothic-Book" panose="02000500000000000000"/>
       <p:regular r:id="rId14"/>
     </p:embeddedFont>
     <p:embeddedFont>
-      <p:font typeface="WPQCJM+FranklinGothic-Book" panose="02000500000000000000" pitchFamily="2" charset="0"/>
+      <p:font typeface="WPQCJM+FranklinGothic-Book" panose="02000500000000000000"/>
       <p:regular r:id="rId15"/>
     </p:embeddedFont>
   </p:embeddedFontLst>
@@ -243,7 +243,7 @@
           <a:p>
             <a:fld id="{C8F60B00-F7D7-A048-9DE8-3D2F737BCA40}" type="datetimeFigureOut">
               <a:rPr lang="en-US" smtClean="0"/>
-              <a:t>3/29/26</a:t>
+              <a:t>3/30/26</a:t>
             </a:fld>
             <a:endParaRPr lang="en-US"/>
           </a:p>
@@ -1832,7 +1832,7 @@
           <a:p>
             <a:fld id="{C16525B2-4347-4F72-BAF7-76B19438D329}" type="datetimeFigureOut">
               <a:rPr lang="en-US" smtClean="0"/>
-              <a:t>3/29/26</a:t>
+              <a:t>3/30/26</a:t>
             </a:fld>
             <a:endParaRPr lang="en-US"/>
           </a:p>
@@ -2055,7 +2055,7 @@
           <a:p>
             <a:fld id="{1D8BD707-D9CF-40AE-B4C6-C98DA3205C09}" type="datetimeFigureOut">
               <a:rPr lang="en-US"/>
-              <a:t>3/29/26</a:t>
+              <a:t>3/30/26</a:t>
             </a:fld>
             <a:endParaRPr lang="en-US"/>
           </a:p>

</xml_diff>